<commit_message>
feat: update ppt layout
</commit_message>
<xml_diff>
--- a/qubit_vs_neuron.pptx
+++ b/qubit_vs_neuron.pptx
@@ -4,6 +4,9 @@
   <p:sldMasterIdLst>
     <p:sldMasterId id="2147483648" r:id="rId1"/>
   </p:sldMasterIdLst>
+  <p:notesMasterIdLst>
+    <p:notesMasterId r:id="rId21"/>
+  </p:notesMasterIdLst>
   <p:sldIdLst>
     <p:sldId id="256" r:id="rId2"/>
     <p:sldId id="257" r:id="rId3"/>
@@ -12,23 +15,20 @@
     <p:sldId id="260" r:id="rId6"/>
     <p:sldId id="261" r:id="rId7"/>
     <p:sldId id="262" r:id="rId8"/>
-    <p:sldId id="263" r:id="rId14"/>
-    <p:sldId id="264" r:id="rId15"/>
-    <p:sldId id="265" r:id="rId16"/>
-    <p:sldId id="266" r:id="rId17"/>
-    <p:sldId id="267" r:id="rId18"/>
-    <p:sldId id="268" r:id="rId19"/>
-    <p:sldId id="269" r:id="rId20"/>
-    <p:sldId id="270" r:id="rId21"/>
-    <p:sldId id="271" r:id="rId22"/>
-    <p:sldId id="272" r:id="rId23"/>
-    <p:sldId id="273" r:id="rId24"/>
-    <p:sldId id="274" r:id="rId25"/>
+    <p:sldId id="263" r:id="rId9"/>
+    <p:sldId id="264" r:id="rId10"/>
+    <p:sldId id="265" r:id="rId11"/>
+    <p:sldId id="266" r:id="rId12"/>
+    <p:sldId id="267" r:id="rId13"/>
+    <p:sldId id="268" r:id="rId14"/>
+    <p:sldId id="269" r:id="rId15"/>
+    <p:sldId id="270" r:id="rId16"/>
+    <p:sldId id="271" r:id="rId17"/>
+    <p:sldId id="272" r:id="rId18"/>
+    <p:sldId id="273" r:id="rId19"/>
+    <p:sldId id="274" r:id="rId20"/>
   </p:sldIdLst>
-  <p:notesMasterIdLst>
-    <p:notesMasterId r:id="rId9"/>
-  </p:notesMasterIdLst>
-  <p:sldSz cx="9144000" cy="5143500"/>
+  <p:sldSz cx="9144000" cy="5143500" type="screen16x9"/>
   <p:notesSz cx="5143500" cy="9144000"/>
   <p:defaultTextStyle>
     <a:lvl1pPr marL="0" algn="l" defTabSz="914400" rtl="0" eaLnBrk="1" latinLnBrk="0" hangingPunct="1">
@@ -122,6 +122,11 @@
       </a:defRPr>
     </a:lvl9pPr>
   </p:defaultTextStyle>
+  <p:extLst>
+    <p:ext uri="{EFAFB233-063F-42B5-8137-9DF3F51BA10A}">
+      <p15:sldGuideLst xmlns:p15="http://schemas.microsoft.com/office/powerpoint/2012/main"/>
+    </p:ext>
+  </p:extLst>
 </p:presentation>
 </file>
 
@@ -147,234 +152,10 @@
           <a:chExt cx="0" cy="0"/>
         </a:xfrm>
       </p:grpSpPr>
-      <p:sp>
-        <p:nvSpPr>
-          <p:cNvPr id="2" name="Header Placeholder 1"/>
-          <p:cNvSpPr>
-            <a:spLocks noGrp="1"/>
-          </p:cNvSpPr>
-          <p:nvPr>
-            <p:ph type="hdr" sz="quarter"/>
-          </p:nvPr>
-        </p:nvSpPr>
-        <p:spPr>
-          <a:xfrm>
-            <a:off x="0" y="0"/>
-            <a:ext cx="2971800" cy="458788"/>
-          </a:xfrm>
-          <a:prstGeom prst="rect">
-            <a:avLst/>
-          </a:prstGeom>
-        </p:spPr>
-        <p:txBody>
-          <a:bodyPr vert="horz" lIns="91440" tIns="45720" rIns="91440" bIns="45720" rtlCol="0"/>
-          <a:lstStyle>
-            <a:lvl1pPr algn="l">
-              <a:defRPr sz="1200"/>
-            </a:lvl1pPr>
-          </a:lstStyle>
-          <a:p>
-            <a:endParaRPr lang="en-US"/>
-          </a:p>
-        </p:txBody>
-      </p:sp>
-      <p:sp>
-        <p:nvSpPr>
-          <p:cNvPr id="3" name="Date Placeholder 2"/>
-          <p:cNvSpPr>
-            <a:spLocks noGrp="1"/>
-          </p:cNvSpPr>
-          <p:nvPr>
-            <p:ph type="dt" idx="1"/>
-          </p:nvPr>
-        </p:nvSpPr>
-        <p:spPr>
-          <a:xfrm>
-            <a:off x="3884613" y="0"/>
-            <a:ext cx="2971800" cy="458788"/>
-          </a:xfrm>
-          <a:prstGeom prst="rect">
-            <a:avLst/>
-          </a:prstGeom>
-        </p:spPr>
-        <p:txBody>
-          <a:bodyPr vert="horz" lIns="91440" tIns="45720" rIns="91440" bIns="45720" rtlCol="0"/>
-          <a:lstStyle>
-            <a:lvl1pPr algn="r">
-              <a:defRPr sz="1200"/>
-            </a:lvl1pPr>
-          </a:lstStyle>
-          <a:p>
-            <a:fld id="{5282F153-3F37-0F45-9E97-73ACFA13230C}" type="datetimeFigureOut">
-              <a:rPr lang="en-US"/>
-              <a:t>7/23/19</a:t>
-            </a:fld>
-            <a:endParaRPr lang="en-US"/>
-          </a:p>
-        </p:txBody>
-      </p:sp>
-      <p:sp>
-        <p:nvSpPr>
-          <p:cNvPr id="4" name="Slide Image Placeholder 3"/>
-          <p:cNvSpPr>
-            <a:spLocks noGrp="1" noRot="1" noChangeAspect="1"/>
-          </p:cNvSpPr>
-          <p:nvPr>
-            <p:ph type="sldImg" idx="2"/>
-          </p:nvPr>
-        </p:nvSpPr>
-        <p:spPr>
-          <a:xfrm>
-            <a:off x="685800" y="1143000"/>
-            <a:ext cx="5486400" cy="3086100"/>
-          </a:xfrm>
-          <a:prstGeom prst="rect">
-            <a:avLst/>
-          </a:prstGeom>
-          <a:noFill/>
-          <a:ln w="12700">
-            <a:solidFill>
-              <a:prstClr val="black"/>
-            </a:solidFill>
-          </a:ln>
-        </p:spPr>
-        <p:txBody>
-          <a:bodyPr vert="horz" lIns="91440" tIns="45720" rIns="91440" bIns="45720" rtlCol="0" anchor="ctr"/>
-          <a:lstStyle/>
-          <a:p>
-            <a:endParaRPr lang="en-US"/>
-          </a:p>
-        </p:txBody>
-      </p:sp>
-      <p:sp>
-        <p:nvSpPr>
-          <p:cNvPr id="5" name="Notes Placeholder 4"/>
-          <p:cNvSpPr>
-            <a:spLocks noGrp="1"/>
-          </p:cNvSpPr>
-          <p:nvPr>
-            <p:ph type="body" sz="quarter" idx="3"/>
-          </p:nvPr>
-        </p:nvSpPr>
-        <p:spPr>
-          <a:xfrm>
-            <a:off x="685800" y="4400550"/>
-            <a:ext cx="5486400" cy="3600450"/>
-          </a:xfrm>
-          <a:prstGeom prst="rect">
-            <a:avLst/>
-          </a:prstGeom>
-        </p:spPr>
-        <p:txBody>
-          <a:bodyPr vert="horz" lIns="91440" tIns="45720" rIns="91440" bIns="45720" rtlCol="0"/>
-          <a:lstStyle/>
-          <a:p>
-            <a:pPr lvl="0"/>
-            <a:r>
-              <a:rPr lang="en-US"/>
-              <a:t>Click to edit Master text styles</a:t>
-            </a:r>
-          </a:p>
-          <a:p>
-            <a:pPr lvl="1"/>
-            <a:r>
-              <a:rPr lang="en-US"/>
-              <a:t>Second level</a:t>
-            </a:r>
-          </a:p>
-          <a:p>
-            <a:pPr lvl="2"/>
-            <a:r>
-              <a:rPr lang="en-US"/>
-              <a:t>Third level</a:t>
-            </a:r>
-          </a:p>
-          <a:p>
-            <a:pPr lvl="3"/>
-            <a:r>
-              <a:rPr lang="en-US"/>
-              <a:t>Fourth level</a:t>
-            </a:r>
-          </a:p>
-          <a:p>
-            <a:pPr lvl="4"/>
-            <a:r>
-              <a:rPr lang="en-US"/>
-              <a:t>Fifth level</a:t>
-            </a:r>
-          </a:p>
-        </p:txBody>
-      </p:sp>
-      <p:sp>
-        <p:nvSpPr>
-          <p:cNvPr id="6" name="Footer Placeholder 5"/>
-          <p:cNvSpPr>
-            <a:spLocks noGrp="1"/>
-          </p:cNvSpPr>
-          <p:nvPr>
-            <p:ph type="ftr" sz="quarter" idx="4"/>
-          </p:nvPr>
-        </p:nvSpPr>
-        <p:spPr>
-          <a:xfrm>
-            <a:off x="0" y="8685213"/>
-            <a:ext cx="2971800" cy="458787"/>
-          </a:xfrm>
-          <a:prstGeom prst="rect">
-            <a:avLst/>
-          </a:prstGeom>
-        </p:spPr>
-        <p:txBody>
-          <a:bodyPr vert="horz" lIns="91440" tIns="45720" rIns="91440" bIns="45720" rtlCol="0" anchor="b"/>
-          <a:lstStyle>
-            <a:lvl1pPr algn="l">
-              <a:defRPr sz="1200"/>
-            </a:lvl1pPr>
-          </a:lstStyle>
-          <a:p>
-            <a:endParaRPr lang="en-US"/>
-          </a:p>
-        </p:txBody>
-      </p:sp>
-      <p:sp>
-        <p:nvSpPr>
-          <p:cNvPr id="7" name="Slide Number Placeholder 6"/>
-          <p:cNvSpPr>
-            <a:spLocks noGrp="1"/>
-          </p:cNvSpPr>
-          <p:nvPr>
-            <p:ph type="sldNum" sz="quarter" idx="5"/>
-          </p:nvPr>
-        </p:nvSpPr>
-        <p:spPr>
-          <a:xfrm>
-            <a:off x="3884613" y="8685213"/>
-            <a:ext cx="2971800" cy="458787"/>
-          </a:xfrm>
-          <a:prstGeom prst="rect">
-            <a:avLst/>
-          </a:prstGeom>
-        </p:spPr>
-        <p:txBody>
-          <a:bodyPr vert="horz" lIns="91440" tIns="45720" rIns="91440" bIns="45720" rtlCol="0" anchor="b"/>
-          <a:lstStyle>
-            <a:lvl1pPr algn="r">
-              <a:defRPr sz="1200"/>
-            </a:lvl1pPr>
-          </a:lstStyle>
-          <a:p>
-            <a:fld id="{CE5E9CC1-C706-0F49-92D6-E571CC5EEA8F}" type="slidenum">
-              <a:rPr lang="en-US"/>
-              <a:t>‹#›</a:t>
-            </a:fld>
-            <a:endParaRPr lang="en-US"/>
-          </a:p>
-        </p:txBody>
-      </p:sp>
     </p:spTree>
     <p:extLst>
       <p:ext uri="{BB962C8B-B14F-4D97-AF65-F5344CB8AC3E}">
-        <p14:creationId xmlns:p14="http://schemas.microsoft.com/office/powerpoint/2010/main" val="1024086991"/>
+        <p14:creationId xmlns:p14="http://schemas.microsoft.com/office/powerpoint/2010/main" val="2075902689"/>
       </p:ext>
     </p:extLst>
   </p:cSld>
@@ -522,7 +303,6 @@
               <a:rPr lang="en-US" dirty="0"/>
               <a:t>Based on the BIJJUDAMA/Qubit-vs-Neuron repository and its case study manuscript.</a:t>
             </a:r>
-            <a:endParaRPr lang="en-US" dirty="0"/>
           </a:p>
         </p:txBody>
       </p:sp>
@@ -610,7 +390,6 @@
               <a:rPr lang="en-US" dirty="0"/>
               <a:t>VQC = parameterized quantum circuit trained in a hybrid loop; compared against a classical MLP under identical splits.</a:t>
             </a:r>
-            <a:endParaRPr lang="en-US" dirty="0"/>
           </a:p>
         </p:txBody>
       </p:sp>
@@ -698,7 +477,6 @@
               <a:rPr lang="en-US" dirty="0"/>
               <a:t>All are binary classification tasks.</a:t>
             </a:r>
-            <a:endParaRPr lang="en-US" dirty="0"/>
           </a:p>
         </p:txBody>
       </p:sp>
@@ -786,7 +564,6 @@
               <a:rPr lang="en-US" dirty="0"/>
               <a:t>Primary backend: PennyLane default.qubit QNodes with the Torch interface and simulator backpropagation (shots=None).</a:t>
             </a:r>
-            <a:endParaRPr lang="en-US" dirty="0"/>
           </a:p>
         </p:txBody>
       </p:sp>
@@ -874,7 +651,6 @@
               <a:rPr lang="en-US" dirty="0"/>
               <a:t>Every figure and table in the manuscript is generated from actual PennyLane executions.</a:t>
             </a:r>
-            <a:endParaRPr lang="en-US" dirty="0"/>
           </a:p>
         </p:txBody>
       </p:sp>
@@ -962,7 +738,6 @@
               <a:rPr lang="en-US" dirty="0"/>
               <a:t>Artifacts live in the results/ folder of the repository.</a:t>
             </a:r>
-            <a:endParaRPr lang="en-US" dirty="0"/>
           </a:p>
         </p:txBody>
       </p:sp>
@@ -1050,7 +825,6 @@
               <a:rPr lang="en-US" dirty="0"/>
               <a:t>Stated by the authors in the repository README.</a:t>
             </a:r>
-            <a:endParaRPr lang="en-US" dirty="0"/>
           </a:p>
         </p:txBody>
       </p:sp>
@@ -1123,6 +897,11 @@
 <file path=ppt/slideMasters/slideMaster1.xml><?xml version="1.0" encoding="utf-8"?>
 <p:sldMaster xmlns:a="http://schemas.openxmlformats.org/drawingml/2006/main" xmlns:r="http://schemas.openxmlformats.org/officeDocument/2006/relationships" xmlns:p="http://schemas.openxmlformats.org/presentationml/2006/main">
   <p:cSld>
+    <p:bg>
+      <p:bgRef idx="1001">
+        <a:schemeClr val="bg1"/>
+      </p:bgRef>
+    </p:bg>
     <p:spTree>
       <p:nvGrpSpPr>
         <p:cNvPr id="1" name=""/>
@@ -1405,6 +1184,7 @@
         <a:solidFill>
           <a:srgbClr val="122743"/>
         </a:solidFill>
+        <a:effectLst/>
       </p:bgPr>
     </p:bg>
     <p:spTree>
@@ -1463,6 +1243,7 @@
           <a:lstStyle/>
           <a:p>
             <a:pPr algn="ctr"/>
+            <a:endParaRPr/>
           </a:p>
         </p:txBody>
       </p:sp>
@@ -1483,7 +1264,7 @@
           <a:noFill/>
         </p:spPr>
         <p:txBody>
-          <a:bodyPr wrap="square" lIns="36576" rIns="36576" tIns="36576" bIns="36576" anchor="t">
+          <a:bodyPr wrap="square" lIns="36576" tIns="36576" rIns="36576" bIns="36576" anchor="t">
             <a:spAutoFit/>
           </a:bodyPr>
           <a:lstStyle/>
@@ -1525,7 +1306,7 @@
           <a:noFill/>
         </p:spPr>
         <p:txBody>
-          <a:bodyPr wrap="square" lIns="36576" rIns="36576" tIns="36576" bIns="36576" anchor="t">
+          <a:bodyPr wrap="square" lIns="36576" tIns="36576" rIns="36576" bIns="36576" anchor="t">
             <a:spAutoFit/>
           </a:bodyPr>
           <a:lstStyle/>
@@ -1567,7 +1348,7 @@
           <a:noFill/>
         </p:spPr>
         <p:txBody>
-          <a:bodyPr wrap="square" lIns="36576" rIns="36576" tIns="36576" bIns="36576" anchor="t">
+          <a:bodyPr wrap="square" lIns="36576" tIns="36576" rIns="36576" bIns="36576" anchor="t">
             <a:spAutoFit/>
           </a:bodyPr>
           <a:lstStyle/>
@@ -1636,6 +1417,7 @@
           <a:lstStyle/>
           <a:p>
             <a:pPr algn="ctr"/>
+            <a:endParaRPr/>
           </a:p>
         </p:txBody>
       </p:sp>
@@ -1656,7 +1438,7 @@
           <a:noFill/>
         </p:spPr>
         <p:txBody>
-          <a:bodyPr wrap="square" lIns="36576" rIns="36576" tIns="36576" bIns="36576" anchor="t">
+          <a:bodyPr wrap="square" lIns="36576" tIns="36576" rIns="36576" bIns="36576" anchor="t">
             <a:spAutoFit/>
           </a:bodyPr>
           <a:lstStyle/>
@@ -1698,7 +1480,7 @@
           <a:noFill/>
         </p:spPr>
         <p:txBody>
-          <a:bodyPr wrap="square" lIns="36576" rIns="36576" tIns="36576" bIns="36576" anchor="t">
+          <a:bodyPr wrap="square" lIns="36576" tIns="36576" rIns="36576" bIns="36576" anchor="t">
             <a:spAutoFit/>
           </a:bodyPr>
           <a:lstStyle/>
@@ -1767,6 +1549,7 @@
           <a:lstStyle/>
           <a:p>
             <a:pPr algn="ctr"/>
+            <a:endParaRPr/>
           </a:p>
         </p:txBody>
       </p:sp>
@@ -1787,7 +1570,7 @@
           <a:noFill/>
         </p:spPr>
         <p:txBody>
-          <a:bodyPr wrap="square" lIns="36576" rIns="36576" tIns="36576" bIns="36576" anchor="t">
+          <a:bodyPr wrap="square" lIns="36576" tIns="36576" rIns="36576" bIns="36576" anchor="t">
             <a:spAutoFit/>
           </a:bodyPr>
           <a:lstStyle/>
@@ -1856,6 +1639,7 @@
           <a:lstStyle/>
           <a:p>
             <a:pPr algn="ctr"/>
+            <a:endParaRPr/>
           </a:p>
         </p:txBody>
       </p:sp>
@@ -1876,7 +1660,7 @@
           <a:noFill/>
         </p:spPr>
         <p:txBody>
-          <a:bodyPr wrap="square" lIns="36576" rIns="36576" tIns="36576" bIns="36576" anchor="t">
+          <a:bodyPr wrap="square" lIns="36576" tIns="36576" rIns="36576" bIns="36576" anchor="t">
             <a:spAutoFit/>
           </a:bodyPr>
           <a:lstStyle/>
@@ -1945,6 +1729,7 @@
           <a:lstStyle/>
           <a:p>
             <a:pPr algn="ctr"/>
+            <a:endParaRPr/>
           </a:p>
         </p:txBody>
       </p:sp>
@@ -1965,7 +1750,7 @@
           <a:noFill/>
         </p:spPr>
         <p:txBody>
-          <a:bodyPr wrap="square" lIns="36576" rIns="36576" tIns="36576" bIns="36576" anchor="t">
+          <a:bodyPr wrap="square" lIns="36576" tIns="36576" rIns="36576" bIns="36576" anchor="t">
             <a:spAutoFit/>
           </a:bodyPr>
           <a:lstStyle/>
@@ -2034,6 +1819,7 @@
           <a:lstStyle/>
           <a:p>
             <a:pPr algn="ctr"/>
+            <a:endParaRPr/>
           </a:p>
         </p:txBody>
       </p:sp>
@@ -2054,7 +1840,7 @@
           <a:noFill/>
         </p:spPr>
         <p:txBody>
-          <a:bodyPr wrap="square" lIns="36576" rIns="36576" tIns="36576" bIns="36576" anchor="t">
+          <a:bodyPr wrap="square" lIns="36576" tIns="36576" rIns="36576" bIns="36576" anchor="t">
             <a:spAutoFit/>
           </a:bodyPr>
           <a:lstStyle/>
@@ -2123,6 +1909,7 @@
           <a:lstStyle/>
           <a:p>
             <a:pPr algn="ctr"/>
+            <a:endParaRPr/>
           </a:p>
         </p:txBody>
       </p:sp>
@@ -2143,7 +1930,7 @@
           <a:noFill/>
         </p:spPr>
         <p:txBody>
-          <a:bodyPr wrap="square" lIns="36576" rIns="36576" tIns="36576" bIns="36576" anchor="t">
+          <a:bodyPr wrap="square" lIns="36576" tIns="36576" rIns="36576" bIns="36576" anchor="t">
             <a:spAutoFit/>
           </a:bodyPr>
           <a:lstStyle/>
@@ -2212,6 +1999,7 @@
           <a:lstStyle/>
           <a:p>
             <a:pPr algn="ctr"/>
+            <a:endParaRPr/>
           </a:p>
         </p:txBody>
       </p:sp>
@@ -2232,7 +2020,7 @@
           <a:noFill/>
         </p:spPr>
         <p:txBody>
-          <a:bodyPr wrap="square" lIns="36576" rIns="36576" tIns="36576" bIns="36576" anchor="t">
+          <a:bodyPr wrap="square" lIns="36576" tIns="36576" rIns="36576" bIns="36576" anchor="t">
             <a:spAutoFit/>
           </a:bodyPr>
           <a:lstStyle/>
@@ -2299,6 +2087,7 @@
           <a:lstStyle/>
           <a:p>
             <a:pPr algn="ctr"/>
+            <a:endParaRPr/>
           </a:p>
         </p:txBody>
       </p:sp>
@@ -2344,6 +2133,7 @@
           <a:lstStyle/>
           <a:p>
             <a:pPr algn="ctr"/>
+            <a:endParaRPr/>
           </a:p>
         </p:txBody>
       </p:sp>
@@ -2389,6 +2179,7 @@
           <a:lstStyle/>
           <a:p>
             <a:pPr algn="ctr"/>
+            <a:endParaRPr/>
           </a:p>
         </p:txBody>
       </p:sp>
@@ -2434,6 +2225,7 @@
           <a:lstStyle/>
           <a:p>
             <a:pPr algn="ctr"/>
+            <a:endParaRPr/>
           </a:p>
         </p:txBody>
       </p:sp>
@@ -2454,7 +2246,7 @@
           <a:noFill/>
         </p:spPr>
         <p:txBody>
-          <a:bodyPr wrap="square" lIns="36576" rIns="36576" tIns="36576" bIns="36576" anchor="t">
+          <a:bodyPr wrap="square" lIns="36576" tIns="36576" rIns="36576" bIns="36576" anchor="t">
             <a:spAutoFit/>
           </a:bodyPr>
           <a:lstStyle/>
@@ -2496,7 +2288,7 @@
           <a:noFill/>
         </p:spPr>
         <p:txBody>
-          <a:bodyPr wrap="square" lIns="36576" rIns="36576" tIns="36576" bIns="36576" anchor="t">
+          <a:bodyPr wrap="square" lIns="36576" tIns="36576" rIns="36576" bIns="36576" anchor="t">
             <a:spAutoFit/>
           </a:bodyPr>
           <a:lstStyle/>
@@ -2530,7 +2322,7 @@
 </file>
 
 <file path=ppt/slides/slide10.xml><?xml version="1.0" encoding="utf-8"?>
-<p:sld xmlns:a="http://schemas.openxmlformats.org/drawingml/2006/main" xmlns:p="http://schemas.openxmlformats.org/presentationml/2006/main" xmlns:r="http://schemas.openxmlformats.org/officeDocument/2006/relationships">
+<p:sld xmlns:a="http://schemas.openxmlformats.org/drawingml/2006/main" xmlns:r="http://schemas.openxmlformats.org/officeDocument/2006/relationships" xmlns:p="http://schemas.openxmlformats.org/presentationml/2006/main">
   <p:cSld>
     <p:bg>
       <p:bgPr>
@@ -2546,7 +2338,14 @@
         <p:cNvGrpSpPr/>
         <p:nvPr/>
       </p:nvGrpSpPr>
-      <p:grpSpPr/>
+      <p:grpSpPr>
+        <a:xfrm>
+          <a:off x="0" y="0"/>
+          <a:ext cx="0" cy="0"/>
+          <a:chOff x="0" y="0"/>
+          <a:chExt cx="0" cy="0"/>
+        </a:xfrm>
+      </p:grpSpPr>
       <p:sp>
         <p:nvSpPr>
           <p:cNvPr id="2" name="Rectangle 1"/>
@@ -2589,6 +2388,7 @@
           <a:lstStyle/>
           <a:p>
             <a:pPr algn="ctr"/>
+            <a:endParaRPr/>
           </a:p>
         </p:txBody>
       </p:sp>
@@ -2609,7 +2409,7 @@
           <a:noFill/>
         </p:spPr>
         <p:txBody>
-          <a:bodyPr wrap="square" lIns="36576" rIns="36576" tIns="36576" bIns="36576" anchor="t">
+          <a:bodyPr wrap="square" lIns="36576" tIns="36576" rIns="36576" bIns="36576" anchor="t">
             <a:spAutoFit/>
           </a:bodyPr>
           <a:lstStyle/>
@@ -2676,6 +2476,7 @@
           <a:lstStyle/>
           <a:p>
             <a:pPr algn="ctr"/>
+            <a:endParaRPr/>
           </a:p>
         </p:txBody>
       </p:sp>
@@ -2696,7 +2497,7 @@
           <a:noFill/>
         </p:spPr>
         <p:txBody>
-          <a:bodyPr wrap="square" lIns="36576" rIns="36576" tIns="36576" bIns="36576" anchor="t">
+          <a:bodyPr wrap="square" lIns="36576" tIns="36576" rIns="36576" bIns="36576" anchor="t">
             <a:spAutoFit/>
           </a:bodyPr>
           <a:lstStyle/>
@@ -2738,7 +2539,7 @@
           <a:noFill/>
         </p:spPr>
         <p:txBody>
-          <a:bodyPr wrap="square" lIns="36576" rIns="36576" tIns="36576" bIns="36576" anchor="t">
+          <a:bodyPr wrap="square" lIns="36576" tIns="36576" rIns="36576" bIns="36576" anchor="t">
             <a:spAutoFit/>
           </a:bodyPr>
           <a:lstStyle/>
@@ -2804,7 +2605,7 @@
           <a:noFill/>
         </p:spPr>
         <p:txBody>
-          <a:bodyPr wrap="square" lIns="36576" rIns="36576" tIns="36576" bIns="36576" anchor="t">
+          <a:bodyPr wrap="square" lIns="36576" tIns="36576" rIns="36576" bIns="36576" anchor="t">
             <a:spAutoFit/>
           </a:bodyPr>
           <a:lstStyle/>
@@ -2838,7 +2639,7 @@
 </file>
 
 <file path=ppt/slides/slide11.xml><?xml version="1.0" encoding="utf-8"?>
-<p:sld xmlns:a="http://schemas.openxmlformats.org/drawingml/2006/main" xmlns:p="http://schemas.openxmlformats.org/presentationml/2006/main" xmlns:r="http://schemas.openxmlformats.org/officeDocument/2006/relationships">
+<p:sld xmlns:a="http://schemas.openxmlformats.org/drawingml/2006/main" xmlns:r="http://schemas.openxmlformats.org/officeDocument/2006/relationships" xmlns:p="http://schemas.openxmlformats.org/presentationml/2006/main">
   <p:cSld>
     <p:bg>
       <p:bgPr>
@@ -2854,7 +2655,14 @@
         <p:cNvGrpSpPr/>
         <p:nvPr/>
       </p:nvGrpSpPr>
-      <p:grpSpPr/>
+      <p:grpSpPr>
+        <a:xfrm>
+          <a:off x="0" y="0"/>
+          <a:ext cx="0" cy="0"/>
+          <a:chOff x="0" y="0"/>
+          <a:chExt cx="0" cy="0"/>
+        </a:xfrm>
+      </p:grpSpPr>
       <p:sp>
         <p:nvSpPr>
           <p:cNvPr id="2" name="Rectangle 1"/>
@@ -2897,6 +2705,7 @@
           <a:lstStyle/>
           <a:p>
             <a:pPr algn="ctr"/>
+            <a:endParaRPr/>
           </a:p>
         </p:txBody>
       </p:sp>
@@ -2917,7 +2726,7 @@
           <a:noFill/>
         </p:spPr>
         <p:txBody>
-          <a:bodyPr wrap="square" lIns="36576" rIns="36576" tIns="36576" bIns="36576" anchor="t">
+          <a:bodyPr wrap="square" lIns="36576" tIns="36576" rIns="36576" bIns="36576" anchor="t">
             <a:spAutoFit/>
           </a:bodyPr>
           <a:lstStyle/>
@@ -2984,6 +2793,7 @@
           <a:lstStyle/>
           <a:p>
             <a:pPr algn="ctr"/>
+            <a:endParaRPr/>
           </a:p>
         </p:txBody>
       </p:sp>
@@ -3004,7 +2814,7 @@
           <a:noFill/>
         </p:spPr>
         <p:txBody>
-          <a:bodyPr wrap="square" lIns="36576" rIns="36576" tIns="36576" bIns="36576" anchor="t">
+          <a:bodyPr wrap="square" lIns="36576" tIns="36576" rIns="36576" bIns="36576" anchor="t">
             <a:spAutoFit/>
           </a:bodyPr>
           <a:lstStyle/>
@@ -3046,7 +2856,7 @@
           <a:noFill/>
         </p:spPr>
         <p:txBody>
-          <a:bodyPr wrap="square" lIns="36576" rIns="36576" tIns="36576" bIns="36576" anchor="t">
+          <a:bodyPr wrap="square" lIns="36576" tIns="36576" rIns="36576" bIns="36576" anchor="t">
             <a:spAutoFit/>
           </a:bodyPr>
           <a:lstStyle/>
@@ -3080,7 +2890,7 @@
           <p:nvPr/>
         </p:nvPicPr>
         <p:blipFill>
-          <a:blip r:embed="rId3"/>
+          <a:blip r:embed="rId2"/>
           <a:stretch>
             <a:fillRect/>
           </a:stretch>
@@ -3104,7 +2914,7 @@
           <p:nvPr/>
         </p:nvPicPr>
         <p:blipFill>
-          <a:blip r:embed="rId4"/>
+          <a:blip r:embed="rId3"/>
           <a:stretch>
             <a:fillRect/>
           </a:stretch>
@@ -3128,7 +2938,7 @@
           <p:nvPr/>
         </p:nvPicPr>
         <p:blipFill>
-          <a:blip r:embed="rId5"/>
+          <a:blip r:embed="rId4"/>
           <a:stretch>
             <a:fillRect/>
           </a:stretch>
@@ -3152,7 +2962,7 @@
           <p:nvPr/>
         </p:nvPicPr>
         <p:blipFill>
-          <a:blip r:embed="rId6"/>
+          <a:blip r:embed="rId5"/>
           <a:stretch>
             <a:fillRect/>
           </a:stretch>
@@ -3184,7 +2994,7 @@
           <a:noFill/>
         </p:spPr>
         <p:txBody>
-          <a:bodyPr wrap="square" lIns="45720" rIns="45720" tIns="27432" bIns="27432">
+          <a:bodyPr wrap="square" lIns="45720" tIns="27432" rIns="45720" bIns="27432">
             <a:spAutoFit/>
           </a:bodyPr>
           <a:lstStyle/>
@@ -3211,7 +3021,7 @@
 </file>
 
 <file path=ppt/slides/slide12.xml><?xml version="1.0" encoding="utf-8"?>
-<p:sld xmlns:a="http://schemas.openxmlformats.org/drawingml/2006/main" xmlns:p="http://schemas.openxmlformats.org/presentationml/2006/main" xmlns:r="http://schemas.openxmlformats.org/officeDocument/2006/relationships">
+<p:sld xmlns:a="http://schemas.openxmlformats.org/drawingml/2006/main" xmlns:r="http://schemas.openxmlformats.org/officeDocument/2006/relationships" xmlns:p="http://schemas.openxmlformats.org/presentationml/2006/main">
   <p:cSld>
     <p:bg>
       <p:bgPr>
@@ -3227,7 +3037,14 @@
         <p:cNvGrpSpPr/>
         <p:nvPr/>
       </p:nvGrpSpPr>
-      <p:grpSpPr/>
+      <p:grpSpPr>
+        <a:xfrm>
+          <a:off x="0" y="0"/>
+          <a:ext cx="0" cy="0"/>
+          <a:chOff x="0" y="0"/>
+          <a:chExt cx="0" cy="0"/>
+        </a:xfrm>
+      </p:grpSpPr>
       <p:sp>
         <p:nvSpPr>
           <p:cNvPr id="2" name="Rectangle 1"/>
@@ -3270,6 +3087,7 @@
           <a:lstStyle/>
           <a:p>
             <a:pPr algn="ctr"/>
+            <a:endParaRPr/>
           </a:p>
         </p:txBody>
       </p:sp>
@@ -3290,7 +3108,7 @@
           <a:noFill/>
         </p:spPr>
         <p:txBody>
-          <a:bodyPr wrap="square" lIns="36576" rIns="36576" tIns="36576" bIns="36576" anchor="t">
+          <a:bodyPr wrap="square" lIns="36576" tIns="36576" rIns="36576" bIns="36576" anchor="t">
             <a:spAutoFit/>
           </a:bodyPr>
           <a:lstStyle/>
@@ -3357,6 +3175,7 @@
           <a:lstStyle/>
           <a:p>
             <a:pPr algn="ctr"/>
+            <a:endParaRPr/>
           </a:p>
         </p:txBody>
       </p:sp>
@@ -3377,7 +3196,7 @@
           <a:noFill/>
         </p:spPr>
         <p:txBody>
-          <a:bodyPr wrap="square" lIns="36576" rIns="36576" tIns="36576" bIns="36576" anchor="t">
+          <a:bodyPr wrap="square" lIns="36576" tIns="36576" rIns="36576" bIns="36576" anchor="t">
             <a:spAutoFit/>
           </a:bodyPr>
           <a:lstStyle/>
@@ -3419,7 +3238,7 @@
           <a:noFill/>
         </p:spPr>
         <p:txBody>
-          <a:bodyPr wrap="square" lIns="36576" rIns="36576" tIns="36576" bIns="36576" anchor="t">
+          <a:bodyPr wrap="square" lIns="36576" tIns="36576" rIns="36576" bIns="36576" anchor="t">
             <a:spAutoFit/>
           </a:bodyPr>
           <a:lstStyle/>
@@ -3488,6 +3307,7 @@
           <a:lstStyle/>
           <a:p>
             <a:pPr algn="ctr"/>
+            <a:endParaRPr/>
           </a:p>
         </p:txBody>
       </p:sp>
@@ -3533,6 +3353,7 @@
           <a:lstStyle/>
           <a:p>
             <a:pPr algn="ctr"/>
+            <a:endParaRPr/>
           </a:p>
         </p:txBody>
       </p:sp>
@@ -3580,6 +3401,7 @@
           <a:lstStyle/>
           <a:p>
             <a:pPr algn="ctr"/>
+            <a:endParaRPr/>
           </a:p>
         </p:txBody>
       </p:sp>
@@ -3625,6 +3447,7 @@
           <a:lstStyle/>
           <a:p>
             <a:pPr algn="ctr"/>
+            <a:endParaRPr/>
           </a:p>
         </p:txBody>
       </p:sp>
@@ -3694,6 +3517,7 @@
           <a:lstStyle/>
           <a:p>
             <a:pPr algn="ctr"/>
+            <a:endParaRPr/>
           </a:p>
         </p:txBody>
       </p:sp>
@@ -3739,6 +3563,7 @@
           <a:lstStyle/>
           <a:p>
             <a:pPr algn="ctr"/>
+            <a:endParaRPr/>
           </a:p>
         </p:txBody>
       </p:sp>
@@ -3759,7 +3584,7 @@
           <a:noFill/>
         </p:spPr>
         <p:txBody>
-          <a:bodyPr wrap="square" lIns="45720" rIns="45720" tIns="27432" bIns="27432">
+          <a:bodyPr wrap="square" lIns="45720" tIns="27432" rIns="45720" bIns="27432">
             <a:spAutoFit/>
           </a:bodyPr>
           <a:lstStyle/>
@@ -3819,6 +3644,7 @@
           <a:lstStyle/>
           <a:p>
             <a:pPr algn="ctr"/>
+            <a:endParaRPr/>
           </a:p>
         </p:txBody>
       </p:sp>
@@ -3864,6 +3690,7 @@
           <a:lstStyle/>
           <a:p>
             <a:pPr algn="ctr"/>
+            <a:endParaRPr/>
           </a:p>
         </p:txBody>
       </p:sp>
@@ -3884,7 +3711,7 @@
           <a:noFill/>
         </p:spPr>
         <p:txBody>
-          <a:bodyPr wrap="square" lIns="45720" rIns="45720" tIns="27432" bIns="27432">
+          <a:bodyPr wrap="square" lIns="45720" tIns="27432" rIns="45720" bIns="27432">
             <a:spAutoFit/>
           </a:bodyPr>
           <a:lstStyle/>
@@ -3919,7 +3746,7 @@
           <a:noFill/>
         </p:spPr>
         <p:txBody>
-          <a:bodyPr wrap="square" lIns="45720" rIns="45720" tIns="27432" bIns="27432">
+          <a:bodyPr wrap="square" lIns="45720" tIns="27432" rIns="45720" bIns="27432">
             <a:spAutoFit/>
           </a:bodyPr>
           <a:lstStyle/>
@@ -3980,7 +3807,7 @@
 </file>
 
 <file path=ppt/slides/slide13.xml><?xml version="1.0" encoding="utf-8"?>
-<p:sld xmlns:a="http://schemas.openxmlformats.org/drawingml/2006/main" xmlns:p="http://schemas.openxmlformats.org/presentationml/2006/main" xmlns:r="http://schemas.openxmlformats.org/officeDocument/2006/relationships">
+<p:sld xmlns:a="http://schemas.openxmlformats.org/drawingml/2006/main" xmlns:r="http://schemas.openxmlformats.org/officeDocument/2006/relationships" xmlns:p="http://schemas.openxmlformats.org/presentationml/2006/main">
   <p:cSld>
     <p:bg>
       <p:bgPr>
@@ -3996,7 +3823,14 @@
         <p:cNvGrpSpPr/>
         <p:nvPr/>
       </p:nvGrpSpPr>
-      <p:grpSpPr/>
+      <p:grpSpPr>
+        <a:xfrm>
+          <a:off x="0" y="0"/>
+          <a:ext cx="0" cy="0"/>
+          <a:chOff x="0" y="0"/>
+          <a:chExt cx="0" cy="0"/>
+        </a:xfrm>
+      </p:grpSpPr>
       <p:sp>
         <p:nvSpPr>
           <p:cNvPr id="2" name="Rectangle 1"/>
@@ -4039,6 +3873,7 @@
           <a:lstStyle/>
           <a:p>
             <a:pPr algn="ctr"/>
+            <a:endParaRPr/>
           </a:p>
         </p:txBody>
       </p:sp>
@@ -4059,7 +3894,7 @@
           <a:noFill/>
         </p:spPr>
         <p:txBody>
-          <a:bodyPr wrap="square" lIns="36576" rIns="36576" tIns="36576" bIns="36576" anchor="t">
+          <a:bodyPr wrap="square" lIns="36576" tIns="36576" rIns="36576" bIns="36576" anchor="t">
             <a:spAutoFit/>
           </a:bodyPr>
           <a:lstStyle/>
@@ -4126,6 +3961,7 @@
           <a:lstStyle/>
           <a:p>
             <a:pPr algn="ctr"/>
+            <a:endParaRPr/>
           </a:p>
         </p:txBody>
       </p:sp>
@@ -4146,7 +3982,7 @@
           <a:noFill/>
         </p:spPr>
         <p:txBody>
-          <a:bodyPr wrap="square" lIns="36576" rIns="36576" tIns="36576" bIns="36576" anchor="t">
+          <a:bodyPr wrap="square" lIns="36576" tIns="36576" rIns="36576" bIns="36576" anchor="t">
             <a:spAutoFit/>
           </a:bodyPr>
           <a:lstStyle/>
@@ -4188,7 +4024,7 @@
           <a:noFill/>
         </p:spPr>
         <p:txBody>
-          <a:bodyPr wrap="square" lIns="36576" rIns="36576" tIns="36576" bIns="36576" anchor="t">
+          <a:bodyPr wrap="square" lIns="36576" tIns="36576" rIns="36576" bIns="36576" anchor="t">
             <a:spAutoFit/>
           </a:bodyPr>
           <a:lstStyle/>
@@ -4281,6 +4117,7 @@
           <a:lstStyle/>
           <a:p>
             <a:pPr algn="ctr"/>
+            <a:endParaRPr/>
           </a:p>
         </p:txBody>
       </p:sp>
@@ -4326,6 +4163,7 @@
           <a:lstStyle/>
           <a:p>
             <a:pPr algn="ctr"/>
+            <a:endParaRPr/>
           </a:p>
         </p:txBody>
       </p:sp>
@@ -4346,7 +4184,7 @@
           <a:noFill/>
         </p:spPr>
         <p:txBody>
-          <a:bodyPr wrap="square" lIns="36576" rIns="36576" tIns="36576" bIns="36576" anchor="t">
+          <a:bodyPr wrap="square" lIns="36576" tIns="36576" rIns="36576" bIns="36576" anchor="t">
             <a:spAutoFit/>
           </a:bodyPr>
           <a:lstStyle/>
@@ -4388,7 +4226,7 @@
           <a:noFill/>
         </p:spPr>
         <p:txBody>
-          <a:bodyPr wrap="square" lIns="36576" rIns="36576" tIns="36576" bIns="36576" anchor="t">
+          <a:bodyPr wrap="square" lIns="36576" tIns="36576" rIns="36576" bIns="36576" anchor="t">
             <a:spAutoFit/>
           </a:bodyPr>
           <a:lstStyle/>
@@ -4457,6 +4295,7 @@
           <a:lstStyle/>
           <a:p>
             <a:pPr algn="ctr"/>
+            <a:endParaRPr/>
           </a:p>
         </p:txBody>
       </p:sp>
@@ -4502,6 +4341,7 @@
           <a:lstStyle/>
           <a:p>
             <a:pPr algn="ctr"/>
+            <a:endParaRPr/>
           </a:p>
         </p:txBody>
       </p:sp>
@@ -4522,7 +4362,7 @@
           <a:noFill/>
         </p:spPr>
         <p:txBody>
-          <a:bodyPr wrap="square" lIns="36576" rIns="36576" tIns="36576" bIns="36576" anchor="t">
+          <a:bodyPr wrap="square" lIns="36576" tIns="36576" rIns="36576" bIns="36576" anchor="t">
             <a:spAutoFit/>
           </a:bodyPr>
           <a:lstStyle/>
@@ -4564,7 +4404,7 @@
           <a:noFill/>
         </p:spPr>
         <p:txBody>
-          <a:bodyPr wrap="square" lIns="36576" rIns="36576" tIns="36576" bIns="36576" anchor="t">
+          <a:bodyPr wrap="square" lIns="36576" tIns="36576" rIns="36576" bIns="36576" anchor="t">
             <a:spAutoFit/>
           </a:bodyPr>
           <a:lstStyle/>
@@ -4598,7 +4438,7 @@
 </file>
 
 <file path=ppt/slides/slide14.xml><?xml version="1.0" encoding="utf-8"?>
-<p:sld xmlns:a="http://schemas.openxmlformats.org/drawingml/2006/main" xmlns:p="http://schemas.openxmlformats.org/presentationml/2006/main" xmlns:r="http://schemas.openxmlformats.org/officeDocument/2006/relationships">
+<p:sld xmlns:a="http://schemas.openxmlformats.org/drawingml/2006/main" xmlns:r="http://schemas.openxmlformats.org/officeDocument/2006/relationships" xmlns:p="http://schemas.openxmlformats.org/presentationml/2006/main">
   <p:cSld>
     <p:bg>
       <p:bgPr>
@@ -4614,7 +4454,14 @@
         <p:cNvGrpSpPr/>
         <p:nvPr/>
       </p:nvGrpSpPr>
-      <p:grpSpPr/>
+      <p:grpSpPr>
+        <a:xfrm>
+          <a:off x="0" y="0"/>
+          <a:ext cx="0" cy="0"/>
+          <a:chOff x="0" y="0"/>
+          <a:chExt cx="0" cy="0"/>
+        </a:xfrm>
+      </p:grpSpPr>
       <p:sp>
         <p:nvSpPr>
           <p:cNvPr id="2" name="Rectangle 1"/>
@@ -4657,6 +4504,7 @@
           <a:lstStyle/>
           <a:p>
             <a:pPr algn="ctr"/>
+            <a:endParaRPr/>
           </a:p>
         </p:txBody>
       </p:sp>
@@ -4677,7 +4525,7 @@
           <a:noFill/>
         </p:spPr>
         <p:txBody>
-          <a:bodyPr wrap="square" lIns="36576" rIns="36576" tIns="36576" bIns="36576" anchor="t">
+          <a:bodyPr wrap="square" lIns="36576" tIns="36576" rIns="36576" bIns="36576" anchor="t">
             <a:spAutoFit/>
           </a:bodyPr>
           <a:lstStyle/>
@@ -4744,6 +4592,7 @@
           <a:lstStyle/>
           <a:p>
             <a:pPr algn="ctr"/>
+            <a:endParaRPr/>
           </a:p>
         </p:txBody>
       </p:sp>
@@ -4764,7 +4613,7 @@
           <a:noFill/>
         </p:spPr>
         <p:txBody>
-          <a:bodyPr wrap="square" lIns="36576" rIns="36576" tIns="36576" bIns="36576" anchor="t">
+          <a:bodyPr wrap="square" lIns="36576" tIns="36576" rIns="36576" bIns="36576" anchor="t">
             <a:spAutoFit/>
           </a:bodyPr>
           <a:lstStyle/>
@@ -4806,7 +4655,7 @@
           <a:noFill/>
         </p:spPr>
         <p:txBody>
-          <a:bodyPr wrap="square" lIns="36576" rIns="36576" tIns="36576" bIns="36576" anchor="t">
+          <a:bodyPr wrap="square" lIns="36576" tIns="36576" rIns="36576" bIns="36576" anchor="t">
             <a:spAutoFit/>
           </a:bodyPr>
           <a:lstStyle/>
@@ -4850,10 +4699,34 @@
                 <a:tableStyleId>{5C22544A-7EE6-4342-B048-85BDC9FD1C3A}</a:tableStyleId>
               </a:tblPr>
               <a:tblGrid>
-                <a:gridCol w="2604211"/>
-                <a:gridCol w="1871776"/>
-                <a:gridCol w="1790395"/>
-                <a:gridCol w="1871776"/>
+                <a:gridCol w="2604211">
+                  <a:extLst>
+                    <a:ext uri="{9D8B030D-6E8A-4147-A177-3AD203B41FA5}">
+                      <a16:colId xmlns:a16="http://schemas.microsoft.com/office/drawing/2014/main" val="20000"/>
+                    </a:ext>
+                  </a:extLst>
+                </a:gridCol>
+                <a:gridCol w="1871776">
+                  <a:extLst>
+                    <a:ext uri="{9D8B030D-6E8A-4147-A177-3AD203B41FA5}">
+                      <a16:colId xmlns:a16="http://schemas.microsoft.com/office/drawing/2014/main" val="20001"/>
+                    </a:ext>
+                  </a:extLst>
+                </a:gridCol>
+                <a:gridCol w="1790395">
+                  <a:extLst>
+                    <a:ext uri="{9D8B030D-6E8A-4147-A177-3AD203B41FA5}">
+                      <a16:colId xmlns:a16="http://schemas.microsoft.com/office/drawing/2014/main" val="20002"/>
+                    </a:ext>
+                  </a:extLst>
+                </a:gridCol>
+                <a:gridCol w="1871776">
+                  <a:extLst>
+                    <a:ext uri="{9D8B030D-6E8A-4147-A177-3AD203B41FA5}">
+                      <a16:colId xmlns:a16="http://schemas.microsoft.com/office/drawing/2014/main" val="20003"/>
+                    </a:ext>
+                  </a:extLst>
+                </a:gridCol>
               </a:tblGrid>
               <a:tr h="374903">
                 <a:tc>
@@ -4948,6 +4821,11 @@
                     </a:solidFill>
                   </a:tcPr>
                 </a:tc>
+                <a:extLst>
+                  <a:ext uri="{0D108BD9-81ED-4DB2-BD59-A6C34878D82A}">
+                    <a16:rowId xmlns:a16="http://schemas.microsoft.com/office/drawing/2014/main" val="10000"/>
+                  </a:ext>
+                </a:extLst>
               </a:tr>
               <a:tr h="374903">
                 <a:tc>
@@ -5042,6 +4920,11 @@
                     </a:solidFill>
                   </a:tcPr>
                 </a:tc>
+                <a:extLst>
+                  <a:ext uri="{0D108BD9-81ED-4DB2-BD59-A6C34878D82A}">
+                    <a16:rowId xmlns:a16="http://schemas.microsoft.com/office/drawing/2014/main" val="10001"/>
+                  </a:ext>
+                </a:extLst>
               </a:tr>
               <a:tr h="374903">
                 <a:tc>
@@ -5136,6 +5019,11 @@
                     </a:solidFill>
                   </a:tcPr>
                 </a:tc>
+                <a:extLst>
+                  <a:ext uri="{0D108BD9-81ED-4DB2-BD59-A6C34878D82A}">
+                    <a16:rowId xmlns:a16="http://schemas.microsoft.com/office/drawing/2014/main" val="10002"/>
+                  </a:ext>
+                </a:extLst>
               </a:tr>
               <a:tr h="374903">
                 <a:tc>
@@ -5230,6 +5118,11 @@
                     </a:solidFill>
                   </a:tcPr>
                 </a:tc>
+                <a:extLst>
+                  <a:ext uri="{0D108BD9-81ED-4DB2-BD59-A6C34878D82A}">
+                    <a16:rowId xmlns:a16="http://schemas.microsoft.com/office/drawing/2014/main" val="10003"/>
+                  </a:ext>
+                </a:extLst>
               </a:tr>
               <a:tr h="374907">
                 <a:tc>
@@ -5324,6 +5217,11 @@
                     </a:solidFill>
                   </a:tcPr>
                 </a:tc>
+                <a:extLst>
+                  <a:ext uri="{0D108BD9-81ED-4DB2-BD59-A6C34878D82A}">
+                    <a16:rowId xmlns:a16="http://schemas.microsoft.com/office/drawing/2014/main" val="10004"/>
+                  </a:ext>
+                </a:extLst>
               </a:tr>
             </a:tbl>
           </a:graphicData>
@@ -5370,7 +5268,7 @@
           <a:noFill/>
         </p:spPr>
         <p:txBody>
-          <a:bodyPr wrap="square" lIns="36576" rIns="36576" tIns="36576" bIns="36576" anchor="t">
+          <a:bodyPr wrap="square" lIns="36576" tIns="36576" rIns="36576" bIns="36576" anchor="t">
             <a:spAutoFit/>
           </a:bodyPr>
           <a:lstStyle/>
@@ -5404,7 +5302,7 @@
 </file>
 
 <file path=ppt/slides/slide15.xml><?xml version="1.0" encoding="utf-8"?>
-<p:sld xmlns:a="http://schemas.openxmlformats.org/drawingml/2006/main" xmlns:p="http://schemas.openxmlformats.org/presentationml/2006/main" xmlns:r="http://schemas.openxmlformats.org/officeDocument/2006/relationships">
+<p:sld xmlns:a="http://schemas.openxmlformats.org/drawingml/2006/main" xmlns:r="http://schemas.openxmlformats.org/officeDocument/2006/relationships" xmlns:p="http://schemas.openxmlformats.org/presentationml/2006/main">
   <p:cSld>
     <p:bg>
       <p:bgPr>
@@ -5420,7 +5318,14 @@
         <p:cNvGrpSpPr/>
         <p:nvPr/>
       </p:nvGrpSpPr>
-      <p:grpSpPr/>
+      <p:grpSpPr>
+        <a:xfrm>
+          <a:off x="0" y="0"/>
+          <a:ext cx="0" cy="0"/>
+          <a:chOff x="0" y="0"/>
+          <a:chExt cx="0" cy="0"/>
+        </a:xfrm>
+      </p:grpSpPr>
       <p:sp>
         <p:nvSpPr>
           <p:cNvPr id="2" name="Rectangle 1"/>
@@ -5463,6 +5368,7 @@
           <a:lstStyle/>
           <a:p>
             <a:pPr algn="ctr"/>
+            <a:endParaRPr/>
           </a:p>
         </p:txBody>
       </p:sp>
@@ -5483,7 +5389,7 @@
           <a:noFill/>
         </p:spPr>
         <p:txBody>
-          <a:bodyPr wrap="square" lIns="27432" rIns="27432" tIns="18288" bIns="18288">
+          <a:bodyPr wrap="square" lIns="27432" tIns="18288" rIns="27432" bIns="18288">
             <a:spAutoFit/>
           </a:bodyPr>
           <a:lstStyle/>
@@ -5543,6 +5449,7 @@
           <a:lstStyle/>
           <a:p>
             <a:pPr algn="ctr"/>
+            <a:endParaRPr/>
           </a:p>
         </p:txBody>
       </p:sp>
@@ -5563,7 +5470,7 @@
           <a:noFill/>
         </p:spPr>
         <p:txBody>
-          <a:bodyPr wrap="square" lIns="27432" rIns="27432" tIns="18288" bIns="18288">
+          <a:bodyPr wrap="square" lIns="27432" tIns="18288" rIns="27432" bIns="18288">
             <a:spAutoFit/>
           </a:bodyPr>
           <a:lstStyle/>
@@ -5598,7 +5505,7 @@
           <a:noFill/>
         </p:spPr>
         <p:txBody>
-          <a:bodyPr wrap="square" lIns="27432" rIns="27432" tIns="18288" bIns="18288">
+          <a:bodyPr wrap="square" lIns="27432" tIns="18288" rIns="27432" bIns="18288">
             <a:spAutoFit/>
           </a:bodyPr>
           <a:lstStyle/>
@@ -5658,6 +5565,7 @@
           <a:lstStyle/>
           <a:p>
             <a:pPr algn="ctr"/>
+            <a:endParaRPr/>
           </a:p>
         </p:txBody>
       </p:sp>
@@ -5703,6 +5611,7 @@
           <a:lstStyle/>
           <a:p>
             <a:pPr algn="ctr"/>
+            <a:endParaRPr/>
           </a:p>
         </p:txBody>
       </p:sp>
@@ -5723,7 +5632,7 @@
           <a:noFill/>
         </p:spPr>
         <p:txBody>
-          <a:bodyPr wrap="square" lIns="27432" rIns="27432" tIns="18288" bIns="18288">
+          <a:bodyPr wrap="square" lIns="27432" tIns="18288" rIns="27432" bIns="18288">
             <a:spAutoFit/>
           </a:bodyPr>
           <a:lstStyle/>
@@ -5758,7 +5667,7 @@
           <a:noFill/>
         </p:spPr>
         <p:txBody>
-          <a:bodyPr wrap="square" lIns="27432" rIns="27432" tIns="18288" bIns="18288">
+          <a:bodyPr wrap="square" lIns="27432" tIns="18288" rIns="27432" bIns="18288">
             <a:spAutoFit/>
           </a:bodyPr>
           <a:lstStyle/>
@@ -5818,6 +5727,7 @@
           <a:lstStyle/>
           <a:p>
             <a:pPr algn="ctr"/>
+            <a:endParaRPr/>
           </a:p>
         </p:txBody>
       </p:sp>
@@ -5863,6 +5773,7 @@
           <a:lstStyle/>
           <a:p>
             <a:pPr algn="ctr"/>
+            <a:endParaRPr/>
           </a:p>
         </p:txBody>
       </p:sp>
@@ -5883,7 +5794,7 @@
           <a:noFill/>
         </p:spPr>
         <p:txBody>
-          <a:bodyPr wrap="square" lIns="27432" rIns="27432" tIns="18288" bIns="18288">
+          <a:bodyPr wrap="square" lIns="27432" tIns="18288" rIns="27432" bIns="18288">
             <a:spAutoFit/>
           </a:bodyPr>
           <a:lstStyle/>
@@ -5918,7 +5829,7 @@
           <a:noFill/>
         </p:spPr>
         <p:txBody>
-          <a:bodyPr wrap="square" lIns="27432" rIns="27432" tIns="18288" bIns="18288">
+          <a:bodyPr wrap="square" lIns="27432" tIns="18288" rIns="27432" bIns="18288">
             <a:spAutoFit/>
           </a:bodyPr>
           <a:lstStyle/>
@@ -5978,6 +5889,7 @@
           <a:lstStyle/>
           <a:p>
             <a:pPr algn="ctr"/>
+            <a:endParaRPr/>
           </a:p>
         </p:txBody>
       </p:sp>
@@ -6023,6 +5935,7 @@
           <a:lstStyle/>
           <a:p>
             <a:pPr algn="ctr"/>
+            <a:endParaRPr/>
           </a:p>
         </p:txBody>
       </p:sp>
@@ -6043,7 +5956,7 @@
           <a:noFill/>
         </p:spPr>
         <p:txBody>
-          <a:bodyPr wrap="square" lIns="27432" rIns="27432" tIns="18288" bIns="18288">
+          <a:bodyPr wrap="square" lIns="27432" tIns="18288" rIns="27432" bIns="18288">
             <a:spAutoFit/>
           </a:bodyPr>
           <a:lstStyle/>
@@ -6078,7 +5991,7 @@
           <a:noFill/>
         </p:spPr>
         <p:txBody>
-          <a:bodyPr wrap="square" lIns="27432" rIns="27432" tIns="18288" bIns="18288">
+          <a:bodyPr wrap="square" lIns="27432" tIns="18288" rIns="27432" bIns="18288">
             <a:spAutoFit/>
           </a:bodyPr>
           <a:lstStyle/>
@@ -6138,6 +6051,7 @@
           <a:lstStyle/>
           <a:p>
             <a:pPr algn="ctr"/>
+            <a:endParaRPr/>
           </a:p>
         </p:txBody>
       </p:sp>
@@ -6183,6 +6097,7 @@
           <a:lstStyle/>
           <a:p>
             <a:pPr algn="ctr"/>
+            <a:endParaRPr/>
           </a:p>
         </p:txBody>
       </p:sp>
@@ -6203,7 +6118,7 @@
           <a:noFill/>
         </p:spPr>
         <p:txBody>
-          <a:bodyPr wrap="square" lIns="27432" rIns="27432" tIns="18288" bIns="18288">
+          <a:bodyPr wrap="square" lIns="27432" tIns="18288" rIns="27432" bIns="18288">
             <a:spAutoFit/>
           </a:bodyPr>
           <a:lstStyle/>
@@ -6238,7 +6153,7 @@
           <a:noFill/>
         </p:spPr>
         <p:txBody>
-          <a:bodyPr wrap="square" lIns="27432" rIns="27432" tIns="18288" bIns="18288">
+          <a:bodyPr wrap="square" lIns="27432" tIns="18288" rIns="27432" bIns="18288">
             <a:spAutoFit/>
           </a:bodyPr>
           <a:lstStyle/>
@@ -6273,7 +6188,7 @@
           <a:noFill/>
         </p:spPr>
         <p:txBody>
-          <a:bodyPr wrap="square" lIns="27432" rIns="27432" tIns="18288" bIns="18288">
+          <a:bodyPr wrap="square" lIns="27432" tIns="18288" rIns="27432" bIns="18288">
             <a:spAutoFit/>
           </a:bodyPr>
           <a:lstStyle/>
@@ -6300,7 +6215,7 @@
 </file>
 
 <file path=ppt/slides/slide16.xml><?xml version="1.0" encoding="utf-8"?>
-<p:sld xmlns:a="http://schemas.openxmlformats.org/drawingml/2006/main" xmlns:p="http://schemas.openxmlformats.org/presentationml/2006/main" xmlns:r="http://schemas.openxmlformats.org/officeDocument/2006/relationships">
+<p:sld xmlns:a="http://schemas.openxmlformats.org/drawingml/2006/main" xmlns:r="http://schemas.openxmlformats.org/officeDocument/2006/relationships" xmlns:p="http://schemas.openxmlformats.org/presentationml/2006/main">
   <p:cSld>
     <p:bg>
       <p:bgPr>
@@ -6316,7 +6231,14 @@
         <p:cNvGrpSpPr/>
         <p:nvPr/>
       </p:nvGrpSpPr>
-      <p:grpSpPr/>
+      <p:grpSpPr>
+        <a:xfrm>
+          <a:off x="0" y="0"/>
+          <a:ext cx="0" cy="0"/>
+          <a:chOff x="0" y="0"/>
+          <a:chExt cx="0" cy="0"/>
+        </a:xfrm>
+      </p:grpSpPr>
       <p:sp>
         <p:nvSpPr>
           <p:cNvPr id="2" name="Rectangle 1"/>
@@ -6359,6 +6281,7 @@
           <a:lstStyle/>
           <a:p>
             <a:pPr algn="ctr"/>
+            <a:endParaRPr/>
           </a:p>
         </p:txBody>
       </p:sp>
@@ -6379,7 +6302,7 @@
           <a:noFill/>
         </p:spPr>
         <p:txBody>
-          <a:bodyPr wrap="square" lIns="36576" rIns="36576" tIns="36576" bIns="36576" anchor="t">
+          <a:bodyPr wrap="square" lIns="36576" tIns="36576" rIns="36576" bIns="36576" anchor="t">
             <a:spAutoFit/>
           </a:bodyPr>
           <a:lstStyle/>
@@ -6446,6 +6369,7 @@
           <a:lstStyle/>
           <a:p>
             <a:pPr algn="ctr"/>
+            <a:endParaRPr/>
           </a:p>
         </p:txBody>
       </p:sp>
@@ -6466,7 +6390,7 @@
           <a:noFill/>
         </p:spPr>
         <p:txBody>
-          <a:bodyPr wrap="square" lIns="36576" rIns="36576" tIns="36576" bIns="36576" anchor="t">
+          <a:bodyPr wrap="square" lIns="36576" tIns="36576" rIns="36576" bIns="36576" anchor="t">
             <a:spAutoFit/>
           </a:bodyPr>
           <a:lstStyle/>
@@ -6508,7 +6432,7 @@
           <a:noFill/>
         </p:spPr>
         <p:txBody>
-          <a:bodyPr wrap="square" lIns="36576" rIns="36576" tIns="36576" bIns="36576" anchor="t">
+          <a:bodyPr wrap="square" lIns="36576" tIns="36576" rIns="36576" bIns="36576" anchor="t">
             <a:spAutoFit/>
           </a:bodyPr>
           <a:lstStyle/>
@@ -6552,9 +6476,27 @@
                 <a:tableStyleId>{5C22544A-7EE6-4342-B048-85BDC9FD1C3A}</a:tableStyleId>
               </a:tblPr>
               <a:tblGrid>
-                <a:gridCol w="3818534"/>
-                <a:gridCol w="2227478"/>
-                <a:gridCol w="1909267"/>
+                <a:gridCol w="3818534">
+                  <a:extLst>
+                    <a:ext uri="{9D8B030D-6E8A-4147-A177-3AD203B41FA5}">
+                      <a16:colId xmlns:a16="http://schemas.microsoft.com/office/drawing/2014/main" val="20000"/>
+                    </a:ext>
+                  </a:extLst>
+                </a:gridCol>
+                <a:gridCol w="2227478">
+                  <a:extLst>
+                    <a:ext uri="{9D8B030D-6E8A-4147-A177-3AD203B41FA5}">
+                      <a16:colId xmlns:a16="http://schemas.microsoft.com/office/drawing/2014/main" val="20001"/>
+                    </a:ext>
+                  </a:extLst>
+                </a:gridCol>
+                <a:gridCol w="1909267">
+                  <a:extLst>
+                    <a:ext uri="{9D8B030D-6E8A-4147-A177-3AD203B41FA5}">
+                      <a16:colId xmlns:a16="http://schemas.microsoft.com/office/drawing/2014/main" val="20002"/>
+                    </a:ext>
+                  </a:extLst>
+                </a:gridCol>
               </a:tblGrid>
               <a:tr h="411480">
                 <a:tc>
@@ -6626,6 +6568,11 @@
                     </a:solidFill>
                   </a:tcPr>
                 </a:tc>
+                <a:extLst>
+                  <a:ext uri="{0D108BD9-81ED-4DB2-BD59-A6C34878D82A}">
+                    <a16:rowId xmlns:a16="http://schemas.microsoft.com/office/drawing/2014/main" val="10000"/>
+                  </a:ext>
+                </a:extLst>
               </a:tr>
               <a:tr h="411480">
                 <a:tc>
@@ -6697,6 +6644,11 @@
                     </a:solidFill>
                   </a:tcPr>
                 </a:tc>
+                <a:extLst>
+                  <a:ext uri="{0D108BD9-81ED-4DB2-BD59-A6C34878D82A}">
+                    <a16:rowId xmlns:a16="http://schemas.microsoft.com/office/drawing/2014/main" val="10001"/>
+                  </a:ext>
+                </a:extLst>
               </a:tr>
               <a:tr h="411480">
                 <a:tc>
@@ -6768,6 +6720,11 @@
                     </a:solidFill>
                   </a:tcPr>
                 </a:tc>
+                <a:extLst>
+                  <a:ext uri="{0D108BD9-81ED-4DB2-BD59-A6C34878D82A}">
+                    <a16:rowId xmlns:a16="http://schemas.microsoft.com/office/drawing/2014/main" val="10002"/>
+                  </a:ext>
+                </a:extLst>
               </a:tr>
               <a:tr h="411480">
                 <a:tc>
@@ -6839,6 +6796,11 @@
                     </a:solidFill>
                   </a:tcPr>
                 </a:tc>
+                <a:extLst>
+                  <a:ext uri="{0D108BD9-81ED-4DB2-BD59-A6C34878D82A}">
+                    <a16:rowId xmlns:a16="http://schemas.microsoft.com/office/drawing/2014/main" val="10003"/>
+                  </a:ext>
+                </a:extLst>
               </a:tr>
               <a:tr h="411480">
                 <a:tc>
@@ -6910,6 +6872,11 @@
                     </a:solidFill>
                   </a:tcPr>
                 </a:tc>
+                <a:extLst>
+                  <a:ext uri="{0D108BD9-81ED-4DB2-BD59-A6C34878D82A}">
+                    <a16:rowId xmlns:a16="http://schemas.microsoft.com/office/drawing/2014/main" val="10004"/>
+                  </a:ext>
+                </a:extLst>
               </a:tr>
               <a:tr h="411480">
                 <a:tc>
@@ -6981,6 +6948,11 @@
                     </a:solidFill>
                   </a:tcPr>
                 </a:tc>
+                <a:extLst>
+                  <a:ext uri="{0D108BD9-81ED-4DB2-BD59-A6C34878D82A}">
+                    <a16:rowId xmlns:a16="http://schemas.microsoft.com/office/drawing/2014/main" val="10005"/>
+                  </a:ext>
+                </a:extLst>
               </a:tr>
             </a:tbl>
           </a:graphicData>
@@ -7030,6 +7002,7 @@
           <a:lstStyle/>
           <a:p>
             <a:pPr algn="ctr"/>
+            <a:endParaRPr/>
           </a:p>
         </p:txBody>
       </p:sp>
@@ -7075,6 +7048,7 @@
           <a:lstStyle/>
           <a:p>
             <a:pPr algn="ctr"/>
+            <a:endParaRPr/>
           </a:p>
         </p:txBody>
       </p:sp>
@@ -7095,7 +7069,7 @@
           <a:noFill/>
         </p:spPr>
         <p:txBody>
-          <a:bodyPr wrap="square" lIns="36576" rIns="36576" tIns="36576" bIns="36576" anchor="t">
+          <a:bodyPr wrap="square" lIns="36576" tIns="36576" rIns="36576" bIns="36576" anchor="t">
             <a:spAutoFit/>
           </a:bodyPr>
           <a:lstStyle/>
@@ -7128,7 +7102,7 @@
         </p:nvSpPr>
         <p:spPr>
           <a:xfrm>
-            <a:off x="786384" y="4315968"/>
+            <a:off x="793242" y="4220609"/>
             <a:ext cx="7607808" cy="173735"/>
           </a:xfrm>
           <a:prstGeom prst="rect">
@@ -7137,7 +7111,7 @@
           <a:noFill/>
         </p:spPr>
         <p:txBody>
-          <a:bodyPr wrap="square" lIns="36576" rIns="36576" tIns="36576" bIns="36576" anchor="t">
+          <a:bodyPr wrap="square" lIns="36576" tIns="36576" rIns="36576" bIns="36576" anchor="t">
             <a:spAutoFit/>
           </a:bodyPr>
           <a:lstStyle/>
@@ -7151,7 +7125,7 @@
               </a:spcAft>
             </a:pPr>
             <a:r>
-              <a:rPr sz="900" b="0" i="0">
+              <a:rPr sz="900" b="0" i="0" dirty="0">
                 <a:solidFill>
                   <a:srgbClr val="1E2F43"/>
                 </a:solidFill>
@@ -7171,7 +7145,7 @@
 </file>
 
 <file path=ppt/slides/slide17.xml><?xml version="1.0" encoding="utf-8"?>
-<p:sld xmlns:a="http://schemas.openxmlformats.org/drawingml/2006/main" xmlns:p="http://schemas.openxmlformats.org/presentationml/2006/main" xmlns:r="http://schemas.openxmlformats.org/officeDocument/2006/relationships">
+<p:sld xmlns:a="http://schemas.openxmlformats.org/drawingml/2006/main" xmlns:r="http://schemas.openxmlformats.org/officeDocument/2006/relationships" xmlns:p="http://schemas.openxmlformats.org/presentationml/2006/main">
   <p:cSld>
     <p:bg>
       <p:bgPr>
@@ -7187,7 +7161,14 @@
         <p:cNvGrpSpPr/>
         <p:nvPr/>
       </p:nvGrpSpPr>
-      <p:grpSpPr/>
+      <p:grpSpPr>
+        <a:xfrm>
+          <a:off x="0" y="0"/>
+          <a:ext cx="0" cy="0"/>
+          <a:chOff x="0" y="0"/>
+          <a:chExt cx="0" cy="0"/>
+        </a:xfrm>
+      </p:grpSpPr>
       <p:sp>
         <p:nvSpPr>
           <p:cNvPr id="2" name="Rectangle 1"/>
@@ -7230,6 +7211,7 @@
           <a:lstStyle/>
           <a:p>
             <a:pPr algn="ctr"/>
+            <a:endParaRPr/>
           </a:p>
         </p:txBody>
       </p:sp>
@@ -7250,7 +7232,7 @@
           <a:noFill/>
         </p:spPr>
         <p:txBody>
-          <a:bodyPr wrap="square" lIns="36576" rIns="36576" tIns="36576" bIns="36576" anchor="t">
+          <a:bodyPr wrap="square" lIns="36576" tIns="36576" rIns="36576" bIns="36576" anchor="t">
             <a:spAutoFit/>
           </a:bodyPr>
           <a:lstStyle/>
@@ -7317,6 +7299,7 @@
           <a:lstStyle/>
           <a:p>
             <a:pPr algn="ctr"/>
+            <a:endParaRPr/>
           </a:p>
         </p:txBody>
       </p:sp>
@@ -7337,7 +7320,7 @@
           <a:noFill/>
         </p:spPr>
         <p:txBody>
-          <a:bodyPr wrap="square" lIns="36576" rIns="36576" tIns="36576" bIns="36576" anchor="t">
+          <a:bodyPr wrap="square" lIns="36576" tIns="36576" rIns="36576" bIns="36576" anchor="t">
             <a:spAutoFit/>
           </a:bodyPr>
           <a:lstStyle/>
@@ -7379,7 +7362,7 @@
           <a:noFill/>
         </p:spPr>
         <p:txBody>
-          <a:bodyPr wrap="square" lIns="36576" rIns="36576" tIns="36576" bIns="36576" anchor="t">
+          <a:bodyPr wrap="square" lIns="36576" tIns="36576" rIns="36576" bIns="36576" anchor="t">
             <a:spAutoFit/>
           </a:bodyPr>
           <a:lstStyle/>
@@ -7472,6 +7455,7 @@
           <a:lstStyle/>
           <a:p>
             <a:pPr algn="ctr"/>
+            <a:endParaRPr/>
           </a:p>
         </p:txBody>
       </p:sp>
@@ -7517,6 +7501,7 @@
           <a:lstStyle/>
           <a:p>
             <a:pPr algn="ctr"/>
+            <a:endParaRPr/>
           </a:p>
         </p:txBody>
       </p:sp>
@@ -7537,7 +7522,7 @@
           <a:noFill/>
         </p:spPr>
         <p:txBody>
-          <a:bodyPr wrap="square" lIns="36576" rIns="36576" tIns="36576" bIns="36576" anchor="t">
+          <a:bodyPr wrap="square" lIns="36576" tIns="36576" rIns="36576" bIns="36576" anchor="t">
             <a:spAutoFit/>
           </a:bodyPr>
           <a:lstStyle/>
@@ -7570,7 +7555,7 @@
         </p:nvSpPr>
         <p:spPr>
           <a:xfrm>
-            <a:off x="786384" y="4617720"/>
+            <a:off x="786384" y="4512564"/>
             <a:ext cx="3447287" cy="64007"/>
           </a:xfrm>
           <a:prstGeom prst="rect">
@@ -7579,7 +7564,7 @@
           <a:noFill/>
         </p:spPr>
         <p:txBody>
-          <a:bodyPr wrap="square" lIns="36576" rIns="36576" tIns="36576" bIns="36576" anchor="t">
+          <a:bodyPr wrap="square" lIns="36576" tIns="36576" rIns="36576" bIns="36576" anchor="t">
             <a:spAutoFit/>
           </a:bodyPr>
           <a:lstStyle/>
@@ -7593,13 +7578,31 @@
               </a:spcAft>
             </a:pPr>
             <a:r>
-              <a:rPr sz="830" b="0" i="0">
+              <a:rPr sz="830" b="0" i="0" dirty="0">
                 <a:solidFill>
                   <a:srgbClr val="1E2F43"/>
                 </a:solidFill>
                 <a:latin typeface="Aptos"/>
               </a:rPr>
-              <a:t>QNN has 7 parameters on 2D tasks and 13 on QDataSet.</a:t>
+              <a:t>QNN has 7 parameters on 2D tasks and 13 on </a:t>
+            </a:r>
+            <a:r>
+              <a:rPr sz="830" b="0" i="0" dirty="0" err="1">
+                <a:solidFill>
+                  <a:srgbClr val="1E2F43"/>
+                </a:solidFill>
+                <a:latin typeface="Aptos"/>
+              </a:rPr>
+              <a:t>QDataSet</a:t>
+            </a:r>
+            <a:r>
+              <a:rPr sz="830" b="0" i="0" dirty="0">
+                <a:solidFill>
+                  <a:srgbClr val="1E2F43"/>
+                </a:solidFill>
+                <a:latin typeface="Aptos"/>
+              </a:rPr>
+              <a:t>.</a:t>
             </a:r>
           </a:p>
         </p:txBody>
@@ -7648,6 +7651,7 @@
           <a:lstStyle/>
           <a:p>
             <a:pPr algn="ctr"/>
+            <a:endParaRPr/>
           </a:p>
         </p:txBody>
       </p:sp>
@@ -7693,6 +7697,7 @@
           <a:lstStyle/>
           <a:p>
             <a:pPr algn="ctr"/>
+            <a:endParaRPr/>
           </a:p>
         </p:txBody>
       </p:sp>
@@ -7713,7 +7718,7 @@
           <a:noFill/>
         </p:spPr>
         <p:txBody>
-          <a:bodyPr wrap="square" lIns="36576" rIns="36576" tIns="36576" bIns="36576" anchor="t">
+          <a:bodyPr wrap="square" lIns="36576" tIns="36576" rIns="36576" bIns="36576" anchor="t">
             <a:spAutoFit/>
           </a:bodyPr>
           <a:lstStyle/>
@@ -7746,7 +7751,7 @@
         </p:nvSpPr>
         <p:spPr>
           <a:xfrm>
-            <a:off x="4809744" y="4617720"/>
+            <a:off x="4791456" y="4512564"/>
             <a:ext cx="3447287" cy="64007"/>
           </a:xfrm>
           <a:prstGeom prst="rect">
@@ -7755,7 +7760,7 @@
           <a:noFill/>
         </p:spPr>
         <p:txBody>
-          <a:bodyPr wrap="square" lIns="36576" rIns="36576" tIns="36576" bIns="36576" anchor="t">
+          <a:bodyPr wrap="square" lIns="36576" tIns="36576" rIns="36576" bIns="36576" anchor="t">
             <a:spAutoFit/>
           </a:bodyPr>
           <a:lstStyle/>
@@ -7769,7 +7774,7 @@
               </a:spcAft>
             </a:pPr>
             <a:r>
-              <a:rPr sz="830" b="0" i="0">
+              <a:rPr sz="830" b="0" i="0" dirty="0">
                 <a:solidFill>
                   <a:srgbClr val="1E2F43"/>
                 </a:solidFill>
@@ -7789,7 +7794,7 @@
 </file>
 
 <file path=ppt/slides/slide18.xml><?xml version="1.0" encoding="utf-8"?>
-<p:sld xmlns:a="http://schemas.openxmlformats.org/drawingml/2006/main" xmlns:p="http://schemas.openxmlformats.org/presentationml/2006/main" xmlns:r="http://schemas.openxmlformats.org/officeDocument/2006/relationships">
+<p:sld xmlns:a="http://schemas.openxmlformats.org/drawingml/2006/main" xmlns:r="http://schemas.openxmlformats.org/officeDocument/2006/relationships" xmlns:p="http://schemas.openxmlformats.org/presentationml/2006/main">
   <p:cSld>
     <p:bg>
       <p:bgPr>
@@ -7805,7 +7810,14 @@
         <p:cNvGrpSpPr/>
         <p:nvPr/>
       </p:nvGrpSpPr>
-      <p:grpSpPr/>
+      <p:grpSpPr>
+        <a:xfrm>
+          <a:off x="0" y="0"/>
+          <a:ext cx="0" cy="0"/>
+          <a:chOff x="0" y="0"/>
+          <a:chExt cx="0" cy="0"/>
+        </a:xfrm>
+      </p:grpSpPr>
       <p:sp>
         <p:nvSpPr>
           <p:cNvPr id="2" name="Rectangle 1"/>
@@ -7848,6 +7860,7 @@
           <a:lstStyle/>
           <a:p>
             <a:pPr algn="ctr"/>
+            <a:endParaRPr/>
           </a:p>
         </p:txBody>
       </p:sp>
@@ -7868,7 +7881,7 @@
           <a:noFill/>
         </p:spPr>
         <p:txBody>
-          <a:bodyPr wrap="square" lIns="36576" rIns="36576" tIns="36576" bIns="36576" anchor="t">
+          <a:bodyPr wrap="square" lIns="36576" tIns="36576" rIns="36576" bIns="36576" anchor="t">
             <a:spAutoFit/>
           </a:bodyPr>
           <a:lstStyle/>
@@ -7935,6 +7948,7 @@
           <a:lstStyle/>
           <a:p>
             <a:pPr algn="ctr"/>
+            <a:endParaRPr/>
           </a:p>
         </p:txBody>
       </p:sp>
@@ -7955,7 +7969,7 @@
           <a:noFill/>
         </p:spPr>
         <p:txBody>
-          <a:bodyPr wrap="square" lIns="36576" rIns="36576" tIns="36576" bIns="36576" anchor="t">
+          <a:bodyPr wrap="square" lIns="36576" tIns="36576" rIns="36576" bIns="36576" anchor="t">
             <a:spAutoFit/>
           </a:bodyPr>
           <a:lstStyle/>
@@ -7997,7 +8011,7 @@
           <a:noFill/>
         </p:spPr>
         <p:txBody>
-          <a:bodyPr wrap="square" lIns="36576" rIns="36576" tIns="36576" bIns="36576" anchor="t">
+          <a:bodyPr wrap="square" lIns="36576" tIns="36576" rIns="36576" bIns="36576" anchor="t">
             <a:spAutoFit/>
           </a:bodyPr>
           <a:lstStyle/>
@@ -8031,7 +8045,7 @@
           <p:nvPr/>
         </p:nvPicPr>
         <p:blipFill>
-          <a:blip r:embed="rId3"/>
+          <a:blip r:embed="rId2"/>
           <a:stretch>
             <a:fillRect/>
           </a:stretch>
@@ -8055,7 +8069,7 @@
           <p:nvPr/>
         </p:nvPicPr>
         <p:blipFill>
-          <a:blip r:embed="rId4"/>
+          <a:blip r:embed="rId3"/>
           <a:stretch>
             <a:fillRect/>
           </a:stretch>
@@ -8079,7 +8093,7 @@
           <p:nvPr/>
         </p:nvPicPr>
         <p:blipFill>
-          <a:blip r:embed="rId5"/>
+          <a:blip r:embed="rId4"/>
           <a:stretch>
             <a:fillRect/>
           </a:stretch>
@@ -8103,7 +8117,7 @@
           <p:nvPr/>
         </p:nvPicPr>
         <p:blipFill>
-          <a:blip r:embed="rId6"/>
+          <a:blip r:embed="rId5"/>
           <a:stretch>
             <a:fillRect/>
           </a:stretch>
@@ -8135,7 +8149,7 @@
           <a:noFill/>
         </p:spPr>
         <p:txBody>
-          <a:bodyPr wrap="square" lIns="27432" rIns="27432" tIns="18288" bIns="18288">
+          <a:bodyPr wrap="square" lIns="27432" tIns="18288" rIns="27432" bIns="18288">
             <a:spAutoFit/>
           </a:bodyPr>
           <a:lstStyle/>
@@ -8162,7 +8176,7 @@
 </file>
 
 <file path=ppt/slides/slide19.xml><?xml version="1.0" encoding="utf-8"?>
-<p:sld xmlns:a="http://schemas.openxmlformats.org/drawingml/2006/main" xmlns:p="http://schemas.openxmlformats.org/presentationml/2006/main" xmlns:r="http://schemas.openxmlformats.org/officeDocument/2006/relationships">
+<p:sld xmlns:a="http://schemas.openxmlformats.org/drawingml/2006/main" xmlns:r="http://schemas.openxmlformats.org/officeDocument/2006/relationships" xmlns:p="http://schemas.openxmlformats.org/presentationml/2006/main">
   <p:cSld>
     <p:bg>
       <p:bgPr>
@@ -8178,7 +8192,14 @@
         <p:cNvGrpSpPr/>
         <p:nvPr/>
       </p:nvGrpSpPr>
-      <p:grpSpPr/>
+      <p:grpSpPr>
+        <a:xfrm>
+          <a:off x="0" y="0"/>
+          <a:ext cx="0" cy="0"/>
+          <a:chOff x="0" y="0"/>
+          <a:chExt cx="0" cy="0"/>
+        </a:xfrm>
+      </p:grpSpPr>
       <p:sp>
         <p:nvSpPr>
           <p:cNvPr id="2" name="Rectangle 1"/>
@@ -8221,6 +8242,7 @@
           <a:lstStyle/>
           <a:p>
             <a:pPr algn="ctr"/>
+            <a:endParaRPr/>
           </a:p>
         </p:txBody>
       </p:sp>
@@ -8241,7 +8263,7 @@
           <a:noFill/>
         </p:spPr>
         <p:txBody>
-          <a:bodyPr wrap="square" lIns="36576" rIns="36576" tIns="36576" bIns="36576" anchor="t">
+          <a:bodyPr wrap="square" lIns="36576" tIns="36576" rIns="36576" bIns="36576" anchor="t">
             <a:spAutoFit/>
           </a:bodyPr>
           <a:lstStyle/>
@@ -8283,7 +8305,7 @@
           <a:noFill/>
         </p:spPr>
         <p:txBody>
-          <a:bodyPr wrap="square" lIns="36576" rIns="36576" tIns="36576" bIns="36576" anchor="t">
+          <a:bodyPr wrap="square" lIns="36576" tIns="36576" rIns="36576" bIns="36576" anchor="t">
             <a:spAutoFit/>
           </a:bodyPr>
           <a:lstStyle/>
@@ -8325,7 +8347,7 @@
           <a:noFill/>
         </p:spPr>
         <p:txBody>
-          <a:bodyPr wrap="square" lIns="36576" rIns="36576" tIns="36576" bIns="36576" anchor="t">
+          <a:bodyPr wrap="square" lIns="36576" tIns="36576" rIns="36576" bIns="36576" anchor="t">
             <a:spAutoFit/>
           </a:bodyPr>
           <a:lstStyle/>
@@ -8394,6 +8416,7 @@
           <a:lstStyle/>
           <a:p>
             <a:pPr algn="ctr"/>
+            <a:endParaRPr/>
           </a:p>
         </p:txBody>
       </p:sp>
@@ -8439,6 +8462,7 @@
           <a:lstStyle/>
           <a:p>
             <a:pPr algn="ctr"/>
+            <a:endParaRPr/>
           </a:p>
         </p:txBody>
       </p:sp>
@@ -8459,7 +8483,7 @@
           <a:noFill/>
         </p:spPr>
         <p:txBody>
-          <a:bodyPr wrap="square" lIns="36576" rIns="36576" tIns="36576" bIns="36576" anchor="t">
+          <a:bodyPr wrap="square" lIns="36576" tIns="36576" rIns="36576" bIns="36576" anchor="t">
             <a:spAutoFit/>
           </a:bodyPr>
           <a:lstStyle/>
@@ -8501,7 +8525,7 @@
           <a:noFill/>
         </p:spPr>
         <p:txBody>
-          <a:bodyPr wrap="square" lIns="45720" rIns="36576" tIns="18288" bIns="18288">
+          <a:bodyPr wrap="square" lIns="45720" tIns="18288" rIns="36576" bIns="18288">
             <a:spAutoFit/>
           </a:bodyPr>
           <a:lstStyle/>
@@ -8583,6 +8607,7 @@
           <a:lstStyle/>
           <a:p>
             <a:pPr algn="ctr"/>
+            <a:endParaRPr/>
           </a:p>
         </p:txBody>
       </p:sp>
@@ -8628,6 +8653,7 @@
           <a:lstStyle/>
           <a:p>
             <a:pPr algn="ctr"/>
+            <a:endParaRPr/>
           </a:p>
         </p:txBody>
       </p:sp>
@@ -8648,7 +8674,7 @@
           <a:noFill/>
         </p:spPr>
         <p:txBody>
-          <a:bodyPr wrap="square" lIns="36576" rIns="36576" tIns="36576" bIns="36576" anchor="t">
+          <a:bodyPr wrap="square" lIns="36576" tIns="36576" rIns="36576" bIns="36576" anchor="t">
             <a:spAutoFit/>
           </a:bodyPr>
           <a:lstStyle/>
@@ -8690,7 +8716,7 @@
           <a:noFill/>
         </p:spPr>
         <p:txBody>
-          <a:bodyPr wrap="square" lIns="45720" rIns="36576" tIns="18288" bIns="18288">
+          <a:bodyPr wrap="square" lIns="45720" tIns="18288" rIns="36576" bIns="18288">
             <a:spAutoFit/>
           </a:bodyPr>
           <a:lstStyle/>
@@ -8772,6 +8798,7 @@
           <a:lstStyle/>
           <a:p>
             <a:pPr algn="ctr"/>
+            <a:endParaRPr/>
           </a:p>
         </p:txBody>
       </p:sp>
@@ -8817,6 +8844,7 @@
           <a:lstStyle/>
           <a:p>
             <a:pPr algn="ctr"/>
+            <a:endParaRPr/>
           </a:p>
         </p:txBody>
       </p:sp>
@@ -8837,7 +8865,7 @@
           <a:noFill/>
         </p:spPr>
         <p:txBody>
-          <a:bodyPr wrap="square" lIns="36576" rIns="36576" tIns="36576" bIns="36576" anchor="t">
+          <a:bodyPr wrap="square" lIns="36576" tIns="36576" rIns="36576" bIns="36576" anchor="t">
             <a:spAutoFit/>
           </a:bodyPr>
           <a:lstStyle/>
@@ -8879,7 +8907,7 @@
           <a:noFill/>
         </p:spPr>
         <p:txBody>
-          <a:bodyPr wrap="square" lIns="45720" rIns="36576" tIns="18288" bIns="18288">
+          <a:bodyPr wrap="square" lIns="45720" tIns="18288" rIns="36576" bIns="18288">
             <a:spAutoFit/>
           </a:bodyPr>
           <a:lstStyle/>
@@ -8961,6 +8989,7 @@
           <a:lstStyle/>
           <a:p>
             <a:pPr algn="ctr"/>
+            <a:endParaRPr/>
           </a:p>
         </p:txBody>
       </p:sp>
@@ -9006,6 +9035,7 @@
           <a:lstStyle/>
           <a:p>
             <a:pPr algn="ctr"/>
+            <a:endParaRPr/>
           </a:p>
         </p:txBody>
       </p:sp>
@@ -9026,7 +9056,7 @@
           <a:noFill/>
         </p:spPr>
         <p:txBody>
-          <a:bodyPr wrap="square" lIns="36576" rIns="36576" tIns="36576" bIns="36576" anchor="t">
+          <a:bodyPr wrap="square" lIns="36576" tIns="36576" rIns="36576" bIns="36576" anchor="t">
             <a:spAutoFit/>
           </a:bodyPr>
           <a:lstStyle/>
@@ -9068,7 +9098,7 @@
           <a:noFill/>
         </p:spPr>
         <p:txBody>
-          <a:bodyPr wrap="square" lIns="36576" rIns="36576" tIns="36576" bIns="36576" anchor="t">
+          <a:bodyPr wrap="square" lIns="36576" tIns="36576" rIns="36576" bIns="36576" anchor="t">
             <a:spAutoFit/>
           </a:bodyPr>
           <a:lstStyle/>
@@ -9110,7 +9140,7 @@
           <a:noFill/>
         </p:spPr>
         <p:txBody>
-          <a:bodyPr wrap="square" lIns="36576" rIns="36576" tIns="36576" bIns="36576" anchor="t">
+          <a:bodyPr wrap="square" lIns="36576" tIns="36576" rIns="36576" bIns="36576" anchor="t">
             <a:spAutoFit/>
           </a:bodyPr>
           <a:lstStyle/>
@@ -9152,7 +9182,7 @@
           <a:noFill/>
         </p:spPr>
         <p:txBody>
-          <a:bodyPr wrap="square" lIns="36576" rIns="36576" tIns="36576" bIns="36576" anchor="t">
+          <a:bodyPr wrap="square" lIns="36576" tIns="36576" rIns="36576" bIns="36576" anchor="t">
             <a:spAutoFit/>
           </a:bodyPr>
           <a:lstStyle/>
@@ -9193,6 +9223,7 @@
         <a:solidFill>
           <a:srgbClr val="FFFFFF"/>
         </a:solidFill>
+        <a:effectLst/>
       </p:bgPr>
     </p:bg>
     <p:spTree>
@@ -9251,6 +9282,7 @@
           <a:lstStyle/>
           <a:p>
             <a:pPr algn="ctr"/>
+            <a:endParaRPr/>
           </a:p>
         </p:txBody>
       </p:sp>
@@ -9271,7 +9303,7 @@
           <a:noFill/>
         </p:spPr>
         <p:txBody>
-          <a:bodyPr wrap="square" lIns="36576" rIns="36576" tIns="36576" bIns="36576" anchor="t">
+          <a:bodyPr wrap="square" lIns="36576" tIns="36576" rIns="36576" bIns="36576" anchor="t">
             <a:spAutoFit/>
           </a:bodyPr>
           <a:lstStyle/>
@@ -9338,6 +9370,7 @@
           <a:lstStyle/>
           <a:p>
             <a:pPr algn="ctr"/>
+            <a:endParaRPr/>
           </a:p>
         </p:txBody>
       </p:sp>
@@ -9358,7 +9391,7 @@
           <a:noFill/>
         </p:spPr>
         <p:txBody>
-          <a:bodyPr wrap="square" lIns="36576" rIns="36576" tIns="36576" bIns="36576" anchor="t">
+          <a:bodyPr wrap="square" lIns="36576" tIns="36576" rIns="36576" bIns="36576" anchor="t">
             <a:spAutoFit/>
           </a:bodyPr>
           <a:lstStyle/>
@@ -9400,7 +9433,7 @@
           <a:noFill/>
         </p:spPr>
         <p:txBody>
-          <a:bodyPr wrap="square" lIns="36576" rIns="36576" tIns="36576" bIns="36576" anchor="t">
+          <a:bodyPr wrap="square" lIns="36576" tIns="36576" rIns="36576" bIns="36576" anchor="t">
             <a:spAutoFit/>
           </a:bodyPr>
           <a:lstStyle/>
@@ -9469,6 +9502,7 @@
           <a:lstStyle/>
           <a:p>
             <a:pPr algn="ctr"/>
+            <a:endParaRPr/>
           </a:p>
         </p:txBody>
       </p:sp>
@@ -9514,6 +9548,7 @@
           <a:lstStyle/>
           <a:p>
             <a:pPr algn="ctr"/>
+            <a:endParaRPr/>
           </a:p>
         </p:txBody>
       </p:sp>
@@ -9534,7 +9569,7 @@
           <a:noFill/>
         </p:spPr>
         <p:txBody>
-          <a:bodyPr wrap="square" lIns="36576" rIns="36576" tIns="36576" bIns="36576" anchor="t">
+          <a:bodyPr wrap="square" lIns="36576" tIns="36576" rIns="36576" bIns="36576" anchor="t">
             <a:spAutoFit/>
           </a:bodyPr>
           <a:lstStyle/>
@@ -9576,7 +9611,7 @@
           <a:noFill/>
         </p:spPr>
         <p:txBody>
-          <a:bodyPr wrap="square" lIns="45720" rIns="36576" tIns="18288" bIns="18288">
+          <a:bodyPr wrap="square" lIns="45720" tIns="18288" rIns="36576" bIns="18288">
             <a:spAutoFit/>
           </a:bodyPr>
           <a:lstStyle/>
@@ -9658,6 +9693,7 @@
           <a:lstStyle/>
           <a:p>
             <a:pPr algn="ctr"/>
+            <a:endParaRPr/>
           </a:p>
         </p:txBody>
       </p:sp>
@@ -9703,6 +9739,7 @@
           <a:lstStyle/>
           <a:p>
             <a:pPr algn="ctr"/>
+            <a:endParaRPr/>
           </a:p>
         </p:txBody>
       </p:sp>
@@ -9723,7 +9760,7 @@
           <a:noFill/>
         </p:spPr>
         <p:txBody>
-          <a:bodyPr wrap="square" lIns="36576" rIns="36576" tIns="36576" bIns="36576" anchor="t">
+          <a:bodyPr wrap="square" lIns="36576" tIns="36576" rIns="36576" bIns="36576" anchor="t">
             <a:spAutoFit/>
           </a:bodyPr>
           <a:lstStyle/>
@@ -9765,7 +9802,7 @@
           <a:noFill/>
         </p:spPr>
         <p:txBody>
-          <a:bodyPr wrap="square" lIns="36576" rIns="36576" tIns="36576" bIns="36576" anchor="t">
+          <a:bodyPr wrap="square" lIns="36576" tIns="36576" rIns="36576" bIns="36576" anchor="t">
             <a:spAutoFit/>
           </a:bodyPr>
           <a:lstStyle/>
@@ -9834,6 +9871,7 @@
           <a:lstStyle/>
           <a:p>
             <a:pPr algn="ctr"/>
+            <a:endParaRPr/>
           </a:p>
         </p:txBody>
       </p:sp>
@@ -9879,6 +9917,7 @@
           <a:lstStyle/>
           <a:p>
             <a:pPr algn="ctr"/>
+            <a:endParaRPr/>
           </a:p>
         </p:txBody>
       </p:sp>
@@ -9899,7 +9938,7 @@
           <a:noFill/>
         </p:spPr>
         <p:txBody>
-          <a:bodyPr wrap="square" lIns="36576" rIns="36576" tIns="36576" bIns="36576" anchor="t">
+          <a:bodyPr wrap="square" lIns="36576" tIns="36576" rIns="36576" bIns="36576" anchor="t">
             <a:spAutoFit/>
           </a:bodyPr>
           <a:lstStyle/>
@@ -9941,7 +9980,7 @@
           <a:noFill/>
         </p:spPr>
         <p:txBody>
-          <a:bodyPr wrap="square" lIns="45720" rIns="36576" tIns="18288" bIns="18288">
+          <a:bodyPr wrap="square" lIns="45720" tIns="18288" rIns="36576" bIns="18288">
             <a:spAutoFit/>
           </a:bodyPr>
           <a:lstStyle/>
@@ -10039,6 +10078,7 @@
           <a:lstStyle/>
           <a:p>
             <a:pPr algn="ctr"/>
+            <a:endParaRPr/>
           </a:p>
         </p:txBody>
       </p:sp>
@@ -10084,6 +10124,7 @@
           <a:lstStyle/>
           <a:p>
             <a:pPr algn="ctr"/>
+            <a:endParaRPr/>
           </a:p>
         </p:txBody>
       </p:sp>
@@ -10104,7 +10145,7 @@
           <a:noFill/>
         </p:spPr>
         <p:txBody>
-          <a:bodyPr wrap="square" lIns="36576" rIns="36576" tIns="36576" bIns="36576" anchor="t">
+          <a:bodyPr wrap="square" lIns="36576" tIns="36576" rIns="36576" bIns="36576" anchor="t">
             <a:spAutoFit/>
           </a:bodyPr>
           <a:lstStyle/>
@@ -10146,7 +10187,7 @@
           <a:noFill/>
         </p:spPr>
         <p:txBody>
-          <a:bodyPr wrap="square" lIns="45720" rIns="36576" tIns="18288" bIns="18288">
+          <a:bodyPr wrap="square" lIns="45720" tIns="18288" rIns="36576" bIns="18288">
             <a:spAutoFit/>
           </a:bodyPr>
           <a:lstStyle/>
@@ -10217,7 +10258,7 @@
           <a:noFill/>
         </p:spPr>
         <p:txBody>
-          <a:bodyPr wrap="square" lIns="36576" rIns="36576" tIns="36576" bIns="36576" anchor="t">
+          <a:bodyPr wrap="square" lIns="36576" tIns="36576" rIns="36576" bIns="36576" anchor="t">
             <a:spAutoFit/>
           </a:bodyPr>
           <a:lstStyle/>
@@ -10258,6 +10299,7 @@
         <a:solidFill>
           <a:srgbClr val="FFFFFF"/>
         </a:solidFill>
+        <a:effectLst/>
       </p:bgPr>
     </p:bg>
     <p:spTree>
@@ -10316,6 +10358,7 @@
           <a:lstStyle/>
           <a:p>
             <a:pPr algn="ctr"/>
+            <a:endParaRPr/>
           </a:p>
         </p:txBody>
       </p:sp>
@@ -10336,7 +10379,7 @@
           <a:noFill/>
         </p:spPr>
         <p:txBody>
-          <a:bodyPr wrap="square" lIns="36576" rIns="36576" tIns="36576" bIns="36576" anchor="t">
+          <a:bodyPr wrap="square" lIns="36576" tIns="36576" rIns="36576" bIns="36576" anchor="t">
             <a:spAutoFit/>
           </a:bodyPr>
           <a:lstStyle/>
@@ -10403,6 +10446,7 @@
           <a:lstStyle/>
           <a:p>
             <a:pPr algn="ctr"/>
+            <a:endParaRPr/>
           </a:p>
         </p:txBody>
       </p:sp>
@@ -10423,7 +10467,7 @@
           <a:noFill/>
         </p:spPr>
         <p:txBody>
-          <a:bodyPr wrap="square" lIns="36576" rIns="36576" tIns="36576" bIns="36576" anchor="t">
+          <a:bodyPr wrap="square" lIns="36576" tIns="36576" rIns="36576" bIns="36576" anchor="t">
             <a:spAutoFit/>
           </a:bodyPr>
           <a:lstStyle/>
@@ -10465,7 +10509,7 @@
           <a:noFill/>
         </p:spPr>
         <p:txBody>
-          <a:bodyPr wrap="square" lIns="36576" rIns="36576" tIns="36576" bIns="36576" anchor="t">
+          <a:bodyPr wrap="square" lIns="36576" tIns="36576" rIns="36576" bIns="36576" anchor="t">
             <a:spAutoFit/>
           </a:bodyPr>
           <a:lstStyle/>
@@ -10534,6 +10578,7 @@
           <a:lstStyle/>
           <a:p>
             <a:pPr algn="ctr"/>
+            <a:endParaRPr/>
           </a:p>
         </p:txBody>
       </p:sp>
@@ -10579,6 +10624,7 @@
           <a:lstStyle/>
           <a:p>
             <a:pPr algn="ctr"/>
+            <a:endParaRPr/>
           </a:p>
         </p:txBody>
       </p:sp>
@@ -10599,7 +10645,7 @@
           <a:noFill/>
         </p:spPr>
         <p:txBody>
-          <a:bodyPr wrap="square" lIns="36576" rIns="36576" tIns="36576" bIns="36576" anchor="t">
+          <a:bodyPr wrap="square" lIns="36576" tIns="36576" rIns="36576" bIns="36576" anchor="t">
             <a:spAutoFit/>
           </a:bodyPr>
           <a:lstStyle/>
@@ -10641,7 +10687,7 @@
           <a:noFill/>
         </p:spPr>
         <p:txBody>
-          <a:bodyPr wrap="square" lIns="45720" rIns="36576" tIns="18288" bIns="18288">
+          <a:bodyPr wrap="square" lIns="45720" tIns="18288" rIns="36576" bIns="18288">
             <a:spAutoFit/>
           </a:bodyPr>
           <a:lstStyle/>
@@ -10739,6 +10785,7 @@
           <a:lstStyle/>
           <a:p>
             <a:pPr algn="ctr"/>
+            <a:endParaRPr/>
           </a:p>
         </p:txBody>
       </p:sp>
@@ -10784,6 +10831,7 @@
           <a:lstStyle/>
           <a:p>
             <a:pPr algn="ctr"/>
+            <a:endParaRPr/>
           </a:p>
         </p:txBody>
       </p:sp>
@@ -10804,7 +10852,7 @@
           <a:noFill/>
         </p:spPr>
         <p:txBody>
-          <a:bodyPr wrap="square" lIns="36576" rIns="36576" tIns="36576" bIns="36576" anchor="t">
+          <a:bodyPr wrap="square" lIns="36576" tIns="36576" rIns="36576" bIns="36576" anchor="t">
             <a:spAutoFit/>
           </a:bodyPr>
           <a:lstStyle/>
@@ -10846,7 +10894,7 @@
           <a:noFill/>
         </p:spPr>
         <p:txBody>
-          <a:bodyPr wrap="square" lIns="45720" rIns="36576" tIns="18288" bIns="18288">
+          <a:bodyPr wrap="square" lIns="45720" tIns="18288" rIns="36576" bIns="18288">
             <a:spAutoFit/>
           </a:bodyPr>
           <a:lstStyle/>
@@ -10944,6 +10992,7 @@
           <a:lstStyle/>
           <a:p>
             <a:pPr algn="ctr"/>
+            <a:endParaRPr/>
           </a:p>
         </p:txBody>
       </p:sp>
@@ -10989,6 +11038,7 @@
           <a:lstStyle/>
           <a:p>
             <a:pPr algn="ctr"/>
+            <a:endParaRPr/>
           </a:p>
         </p:txBody>
       </p:sp>
@@ -11009,7 +11059,7 @@
           <a:noFill/>
         </p:spPr>
         <p:txBody>
-          <a:bodyPr wrap="square" lIns="36576" rIns="36576" tIns="36576" bIns="36576" anchor="t">
+          <a:bodyPr wrap="square" lIns="36576" tIns="36576" rIns="36576" bIns="36576" anchor="t">
             <a:spAutoFit/>
           </a:bodyPr>
           <a:lstStyle/>
@@ -11051,7 +11101,7 @@
           <a:noFill/>
         </p:spPr>
         <p:txBody>
-          <a:bodyPr wrap="square" lIns="45720" rIns="36576" tIns="18288" bIns="18288">
+          <a:bodyPr wrap="square" lIns="45720" tIns="18288" rIns="36576" bIns="18288">
             <a:spAutoFit/>
           </a:bodyPr>
           <a:lstStyle/>
@@ -11149,6 +11199,7 @@
           <a:lstStyle/>
           <a:p>
             <a:pPr algn="ctr"/>
+            <a:endParaRPr/>
           </a:p>
         </p:txBody>
       </p:sp>
@@ -11194,6 +11245,7 @@
           <a:lstStyle/>
           <a:p>
             <a:pPr algn="ctr"/>
+            <a:endParaRPr/>
           </a:p>
         </p:txBody>
       </p:sp>
@@ -11214,7 +11266,7 @@
           <a:noFill/>
         </p:spPr>
         <p:txBody>
-          <a:bodyPr wrap="square" lIns="36576" rIns="36576" tIns="36576" bIns="36576" anchor="t">
+          <a:bodyPr wrap="square" lIns="36576" tIns="36576" rIns="36576" bIns="36576" anchor="t">
             <a:spAutoFit/>
           </a:bodyPr>
           <a:lstStyle/>
@@ -11256,7 +11308,7 @@
           <a:noFill/>
         </p:spPr>
         <p:txBody>
-          <a:bodyPr wrap="square" lIns="45720" rIns="36576" tIns="18288" bIns="18288">
+          <a:bodyPr wrap="square" lIns="45720" tIns="18288" rIns="36576" bIns="18288">
             <a:spAutoFit/>
           </a:bodyPr>
           <a:lstStyle/>
@@ -11327,7 +11379,7 @@
           <a:noFill/>
         </p:spPr>
         <p:txBody>
-          <a:bodyPr wrap="square" lIns="36576" rIns="36576" tIns="36576" bIns="36576" anchor="t">
+          <a:bodyPr wrap="square" lIns="36576" tIns="36576" rIns="36576" bIns="36576" anchor="t">
             <a:spAutoFit/>
           </a:bodyPr>
           <a:lstStyle/>
@@ -11368,6 +11420,7 @@
         <a:solidFill>
           <a:srgbClr val="FFFFFF"/>
         </a:solidFill>
+        <a:effectLst/>
       </p:bgPr>
     </p:bg>
     <p:spTree>
@@ -11426,6 +11479,7 @@
           <a:lstStyle/>
           <a:p>
             <a:pPr algn="ctr"/>
+            <a:endParaRPr/>
           </a:p>
         </p:txBody>
       </p:sp>
@@ -11446,7 +11500,7 @@
           <a:noFill/>
         </p:spPr>
         <p:txBody>
-          <a:bodyPr wrap="square" lIns="36576" rIns="36576" tIns="36576" bIns="36576" anchor="t">
+          <a:bodyPr wrap="square" lIns="36576" tIns="36576" rIns="36576" bIns="36576" anchor="t">
             <a:spAutoFit/>
           </a:bodyPr>
           <a:lstStyle/>
@@ -11513,6 +11567,7 @@
           <a:lstStyle/>
           <a:p>
             <a:pPr algn="ctr"/>
+            <a:endParaRPr/>
           </a:p>
         </p:txBody>
       </p:sp>
@@ -11533,7 +11588,7 @@
           <a:noFill/>
         </p:spPr>
         <p:txBody>
-          <a:bodyPr wrap="square" lIns="36576" rIns="36576" tIns="36576" bIns="36576" anchor="t">
+          <a:bodyPr wrap="square" lIns="36576" tIns="36576" rIns="36576" bIns="36576" anchor="t">
             <a:spAutoFit/>
           </a:bodyPr>
           <a:lstStyle/>
@@ -11575,7 +11630,7 @@
           <a:noFill/>
         </p:spPr>
         <p:txBody>
-          <a:bodyPr wrap="square" lIns="36576" rIns="36576" tIns="36576" bIns="36576" anchor="t">
+          <a:bodyPr wrap="square" lIns="36576" tIns="36576" rIns="36576" bIns="36576" anchor="t">
             <a:spAutoFit/>
           </a:bodyPr>
           <a:lstStyle/>
@@ -11644,6 +11699,7 @@
           <a:lstStyle/>
           <a:p>
             <a:pPr algn="ctr"/>
+            <a:endParaRPr/>
           </a:p>
         </p:txBody>
       </p:sp>
@@ -11691,6 +11747,7 @@
           <a:lstStyle/>
           <a:p>
             <a:pPr algn="ctr"/>
+            <a:endParaRPr/>
           </a:p>
         </p:txBody>
       </p:sp>
@@ -11711,7 +11768,7 @@
           <a:noFill/>
         </p:spPr>
         <p:txBody>
-          <a:bodyPr wrap="square" lIns="36576" rIns="36576" tIns="36576" bIns="36576" anchor="t">
+          <a:bodyPr wrap="square" lIns="36576" tIns="36576" rIns="36576" bIns="36576" anchor="t">
             <a:spAutoFit/>
           </a:bodyPr>
           <a:lstStyle/>
@@ -11753,7 +11810,7 @@
           <a:noFill/>
         </p:spPr>
         <p:txBody>
-          <a:bodyPr wrap="square" lIns="36576" rIns="36576" tIns="36576" bIns="36576" anchor="t">
+          <a:bodyPr wrap="square" lIns="36576" tIns="36576" rIns="36576" bIns="36576" anchor="t">
             <a:spAutoFit/>
           </a:bodyPr>
           <a:lstStyle/>
@@ -11795,7 +11852,7 @@
           <a:noFill/>
         </p:spPr>
         <p:txBody>
-          <a:bodyPr wrap="square" lIns="36576" rIns="36576" tIns="36576" bIns="36576" anchor="t">
+          <a:bodyPr wrap="square" lIns="36576" tIns="36576" rIns="36576" bIns="36576" anchor="t">
             <a:spAutoFit/>
           </a:bodyPr>
           <a:lstStyle/>
@@ -11837,7 +11894,7 @@
           <a:noFill/>
         </p:spPr>
         <p:txBody>
-          <a:bodyPr wrap="square" lIns="36576" rIns="36576" tIns="36576" bIns="36576" anchor="t">
+          <a:bodyPr wrap="square" lIns="36576" tIns="36576" rIns="36576" bIns="36576" anchor="t">
             <a:spAutoFit/>
           </a:bodyPr>
           <a:lstStyle/>
@@ -11906,6 +11963,7 @@
           <a:lstStyle/>
           <a:p>
             <a:pPr algn="ctr"/>
+            <a:endParaRPr/>
           </a:p>
         </p:txBody>
       </p:sp>
@@ -11953,6 +12011,7 @@
           <a:lstStyle/>
           <a:p>
             <a:pPr algn="ctr"/>
+            <a:endParaRPr/>
           </a:p>
         </p:txBody>
       </p:sp>
@@ -11973,7 +12032,7 @@
           <a:noFill/>
         </p:spPr>
         <p:txBody>
-          <a:bodyPr wrap="square" lIns="36576" rIns="36576" tIns="36576" bIns="36576" anchor="t">
+          <a:bodyPr wrap="square" lIns="36576" tIns="36576" rIns="36576" bIns="36576" anchor="t">
             <a:spAutoFit/>
           </a:bodyPr>
           <a:lstStyle/>
@@ -12015,7 +12074,7 @@
           <a:noFill/>
         </p:spPr>
         <p:txBody>
-          <a:bodyPr wrap="square" lIns="36576" rIns="36576" tIns="36576" bIns="36576" anchor="t">
+          <a:bodyPr wrap="square" lIns="36576" tIns="36576" rIns="36576" bIns="36576" anchor="t">
             <a:spAutoFit/>
           </a:bodyPr>
           <a:lstStyle/>
@@ -12057,7 +12116,7 @@
           <a:noFill/>
         </p:spPr>
         <p:txBody>
-          <a:bodyPr wrap="square" lIns="36576" rIns="36576" tIns="36576" bIns="36576" anchor="t">
+          <a:bodyPr wrap="square" lIns="36576" tIns="36576" rIns="36576" bIns="36576" anchor="t">
             <a:spAutoFit/>
           </a:bodyPr>
           <a:lstStyle/>
@@ -12099,7 +12158,7 @@
           <a:noFill/>
         </p:spPr>
         <p:txBody>
-          <a:bodyPr wrap="square" lIns="36576" rIns="36576" tIns="36576" bIns="36576" anchor="t">
+          <a:bodyPr wrap="square" lIns="36576" tIns="36576" rIns="36576" bIns="36576" anchor="t">
             <a:spAutoFit/>
           </a:bodyPr>
           <a:lstStyle/>
@@ -12168,6 +12227,7 @@
           <a:lstStyle/>
           <a:p>
             <a:pPr algn="ctr"/>
+            <a:endParaRPr/>
           </a:p>
         </p:txBody>
       </p:sp>
@@ -12215,6 +12275,7 @@
           <a:lstStyle/>
           <a:p>
             <a:pPr algn="ctr"/>
+            <a:endParaRPr/>
           </a:p>
         </p:txBody>
       </p:sp>
@@ -12235,7 +12296,7 @@
           <a:noFill/>
         </p:spPr>
         <p:txBody>
-          <a:bodyPr wrap="square" lIns="36576" rIns="36576" tIns="36576" bIns="36576" anchor="t">
+          <a:bodyPr wrap="square" lIns="36576" tIns="36576" rIns="36576" bIns="36576" anchor="t">
             <a:spAutoFit/>
           </a:bodyPr>
           <a:lstStyle/>
@@ -12277,7 +12338,7 @@
           <a:noFill/>
         </p:spPr>
         <p:txBody>
-          <a:bodyPr wrap="square" lIns="36576" rIns="36576" tIns="36576" bIns="36576" anchor="t">
+          <a:bodyPr wrap="square" lIns="36576" tIns="36576" rIns="36576" bIns="36576" anchor="t">
             <a:spAutoFit/>
           </a:bodyPr>
           <a:lstStyle/>
@@ -12319,7 +12380,7 @@
           <a:noFill/>
         </p:spPr>
         <p:txBody>
-          <a:bodyPr wrap="square" lIns="36576" rIns="36576" tIns="36576" bIns="36576" anchor="t">
+          <a:bodyPr wrap="square" lIns="36576" tIns="36576" rIns="36576" bIns="36576" anchor="t">
             <a:spAutoFit/>
           </a:bodyPr>
           <a:lstStyle/>
@@ -12361,7 +12422,7 @@
           <a:noFill/>
         </p:spPr>
         <p:txBody>
-          <a:bodyPr wrap="square" lIns="36576" rIns="36576" tIns="36576" bIns="36576" anchor="t">
+          <a:bodyPr wrap="square" lIns="36576" tIns="36576" rIns="36576" bIns="36576" anchor="t">
             <a:spAutoFit/>
           </a:bodyPr>
           <a:lstStyle/>
@@ -12430,6 +12491,7 @@
           <a:lstStyle/>
           <a:p>
             <a:pPr algn="ctr"/>
+            <a:endParaRPr/>
           </a:p>
         </p:txBody>
       </p:sp>
@@ -12477,6 +12539,7 @@
           <a:lstStyle/>
           <a:p>
             <a:pPr algn="ctr"/>
+            <a:endParaRPr/>
           </a:p>
         </p:txBody>
       </p:sp>
@@ -12497,7 +12560,7 @@
           <a:noFill/>
         </p:spPr>
         <p:txBody>
-          <a:bodyPr wrap="square" lIns="36576" rIns="36576" tIns="36576" bIns="36576" anchor="t">
+          <a:bodyPr wrap="square" lIns="36576" tIns="36576" rIns="36576" bIns="36576" anchor="t">
             <a:spAutoFit/>
           </a:bodyPr>
           <a:lstStyle/>
@@ -12539,7 +12602,7 @@
           <a:noFill/>
         </p:spPr>
         <p:txBody>
-          <a:bodyPr wrap="square" lIns="36576" rIns="36576" tIns="36576" bIns="36576" anchor="t">
+          <a:bodyPr wrap="square" lIns="36576" tIns="36576" rIns="36576" bIns="36576" anchor="t">
             <a:spAutoFit/>
           </a:bodyPr>
           <a:lstStyle/>
@@ -12581,7 +12644,7 @@
           <a:noFill/>
         </p:spPr>
         <p:txBody>
-          <a:bodyPr wrap="square" lIns="36576" rIns="36576" tIns="36576" bIns="36576" anchor="t">
+          <a:bodyPr wrap="square" lIns="36576" tIns="36576" rIns="36576" bIns="36576" anchor="t">
             <a:spAutoFit/>
           </a:bodyPr>
           <a:lstStyle/>
@@ -12623,7 +12686,7 @@
           <a:noFill/>
         </p:spPr>
         <p:txBody>
-          <a:bodyPr wrap="square" lIns="36576" rIns="36576" tIns="36576" bIns="36576" anchor="t">
+          <a:bodyPr wrap="square" lIns="36576" tIns="36576" rIns="36576" bIns="36576" anchor="t">
             <a:spAutoFit/>
           </a:bodyPr>
           <a:lstStyle/>
@@ -12692,6 +12755,7 @@
           <a:lstStyle/>
           <a:p>
             <a:pPr algn="ctr"/>
+            <a:endParaRPr/>
           </a:p>
         </p:txBody>
       </p:sp>
@@ -12739,6 +12803,7 @@
           <a:lstStyle/>
           <a:p>
             <a:pPr algn="ctr"/>
+            <a:endParaRPr/>
           </a:p>
         </p:txBody>
       </p:sp>
@@ -12759,7 +12824,7 @@
           <a:noFill/>
         </p:spPr>
         <p:txBody>
-          <a:bodyPr wrap="square" lIns="36576" rIns="36576" tIns="36576" bIns="36576" anchor="t">
+          <a:bodyPr wrap="square" lIns="36576" tIns="36576" rIns="36576" bIns="36576" anchor="t">
             <a:spAutoFit/>
           </a:bodyPr>
           <a:lstStyle/>
@@ -12801,7 +12866,7 @@
           <a:noFill/>
         </p:spPr>
         <p:txBody>
-          <a:bodyPr wrap="square" lIns="36576" rIns="36576" tIns="36576" bIns="36576" anchor="t">
+          <a:bodyPr wrap="square" lIns="36576" tIns="36576" rIns="36576" bIns="36576" anchor="t">
             <a:spAutoFit/>
           </a:bodyPr>
           <a:lstStyle/>
@@ -12843,7 +12908,7 @@
           <a:noFill/>
         </p:spPr>
         <p:txBody>
-          <a:bodyPr wrap="square" lIns="36576" rIns="36576" tIns="36576" bIns="36576" anchor="t">
+          <a:bodyPr wrap="square" lIns="36576" tIns="36576" rIns="36576" bIns="36576" anchor="t">
             <a:spAutoFit/>
           </a:bodyPr>
           <a:lstStyle/>
@@ -12912,6 +12977,7 @@
           <a:lstStyle/>
           <a:p>
             <a:pPr algn="ctr"/>
+            <a:endParaRPr/>
           </a:p>
         </p:txBody>
       </p:sp>
@@ -12932,7 +12998,7 @@
           <a:noFill/>
         </p:spPr>
         <p:txBody>
-          <a:bodyPr wrap="square" lIns="36576" rIns="36576" tIns="36576" bIns="36576" anchor="t">
+          <a:bodyPr wrap="square" lIns="36576" tIns="36576" rIns="36576" bIns="36576" anchor="t">
             <a:spAutoFit/>
           </a:bodyPr>
           <a:lstStyle/>
@@ -12974,7 +13040,7 @@
           <a:noFill/>
         </p:spPr>
         <p:txBody>
-          <a:bodyPr wrap="square" lIns="36576" rIns="36576" tIns="36576" bIns="36576" anchor="t">
+          <a:bodyPr wrap="square" lIns="36576" tIns="36576" rIns="36576" bIns="36576" anchor="t">
             <a:spAutoFit/>
           </a:bodyPr>
           <a:lstStyle/>
@@ -13015,6 +13081,7 @@
         <a:solidFill>
           <a:srgbClr val="FFFFFF"/>
         </a:solidFill>
+        <a:effectLst/>
       </p:bgPr>
     </p:bg>
     <p:spTree>
@@ -13073,6 +13140,7 @@
           <a:lstStyle/>
           <a:p>
             <a:pPr algn="ctr"/>
+            <a:endParaRPr/>
           </a:p>
         </p:txBody>
       </p:sp>
@@ -13093,7 +13161,7 @@
           <a:noFill/>
         </p:spPr>
         <p:txBody>
-          <a:bodyPr wrap="square" lIns="36576" rIns="36576" tIns="36576" bIns="36576" anchor="t">
+          <a:bodyPr wrap="square" lIns="36576" tIns="36576" rIns="36576" bIns="36576" anchor="t">
             <a:spAutoFit/>
           </a:bodyPr>
           <a:lstStyle/>
@@ -13160,6 +13228,7 @@
           <a:lstStyle/>
           <a:p>
             <a:pPr algn="ctr"/>
+            <a:endParaRPr/>
           </a:p>
         </p:txBody>
       </p:sp>
@@ -13180,7 +13249,7 @@
           <a:noFill/>
         </p:spPr>
         <p:txBody>
-          <a:bodyPr wrap="square" lIns="36576" rIns="36576" tIns="36576" bIns="36576" anchor="t">
+          <a:bodyPr wrap="square" lIns="36576" tIns="36576" rIns="36576" bIns="36576" anchor="t">
             <a:spAutoFit/>
           </a:bodyPr>
           <a:lstStyle/>
@@ -13222,7 +13291,7 @@
           <a:noFill/>
         </p:spPr>
         <p:txBody>
-          <a:bodyPr wrap="square" lIns="36576" rIns="36576" tIns="36576" bIns="36576" anchor="t">
+          <a:bodyPr wrap="square" lIns="36576" tIns="36576" rIns="36576" bIns="36576" anchor="t">
             <a:spAutoFit/>
           </a:bodyPr>
           <a:lstStyle/>
@@ -13291,6 +13360,7 @@
           <a:lstStyle/>
           <a:p>
             <a:pPr algn="ctr"/>
+            <a:endParaRPr/>
           </a:p>
         </p:txBody>
       </p:sp>
@@ -13336,6 +13406,7 @@
           <a:lstStyle/>
           <a:p>
             <a:pPr algn="ctr"/>
+            <a:endParaRPr/>
           </a:p>
         </p:txBody>
       </p:sp>
@@ -13356,7 +13427,7 @@
           <a:noFill/>
         </p:spPr>
         <p:txBody>
-          <a:bodyPr wrap="square" lIns="36576" rIns="36576" tIns="36576" bIns="36576" anchor="t">
+          <a:bodyPr wrap="square" lIns="36576" tIns="36576" rIns="36576" bIns="36576" anchor="t">
             <a:spAutoFit/>
           </a:bodyPr>
           <a:lstStyle/>
@@ -13398,7 +13469,7 @@
           <a:noFill/>
         </p:spPr>
         <p:txBody>
-          <a:bodyPr wrap="square" lIns="45720" rIns="36576" tIns="18288" bIns="18288">
+          <a:bodyPr wrap="square" lIns="45720" tIns="18288" rIns="36576" bIns="18288">
             <a:spAutoFit/>
           </a:bodyPr>
           <a:lstStyle/>
@@ -13544,6 +13615,7 @@
           <a:lstStyle/>
           <a:p>
             <a:pPr algn="ctr"/>
+            <a:endParaRPr/>
           </a:p>
         </p:txBody>
       </p:sp>
@@ -13589,6 +13661,7 @@
           <a:lstStyle/>
           <a:p>
             <a:pPr algn="ctr"/>
+            <a:endParaRPr/>
           </a:p>
         </p:txBody>
       </p:sp>
@@ -13609,7 +13682,7 @@
           <a:noFill/>
         </p:spPr>
         <p:txBody>
-          <a:bodyPr wrap="square" lIns="36576" rIns="36576" tIns="36576" bIns="36576" anchor="t">
+          <a:bodyPr wrap="square" lIns="36576" tIns="36576" rIns="36576" bIns="36576" anchor="t">
             <a:spAutoFit/>
           </a:bodyPr>
           <a:lstStyle/>
@@ -13651,7 +13724,7 @@
           <a:noFill/>
         </p:spPr>
         <p:txBody>
-          <a:bodyPr wrap="square" lIns="45720" rIns="36576" tIns="18288" bIns="18288">
+          <a:bodyPr wrap="square" lIns="45720" tIns="18288" rIns="36576" bIns="18288">
             <a:spAutoFit/>
           </a:bodyPr>
           <a:lstStyle/>
@@ -13781,6 +13854,7 @@
           <a:lstStyle/>
           <a:p>
             <a:pPr algn="ctr"/>
+            <a:endParaRPr/>
           </a:p>
         </p:txBody>
       </p:sp>
@@ -13801,7 +13875,7 @@
           <a:noFill/>
         </p:spPr>
         <p:txBody>
-          <a:bodyPr wrap="square" lIns="36576" rIns="36576" tIns="36576" bIns="36576" anchor="t">
+          <a:bodyPr wrap="square" lIns="36576" tIns="36576" rIns="36576" bIns="36576" anchor="t">
             <a:spAutoFit/>
           </a:bodyPr>
           <a:lstStyle/>
@@ -13842,6 +13916,7 @@
         <a:solidFill>
           <a:srgbClr val="FFFFFF"/>
         </a:solidFill>
+        <a:effectLst/>
       </p:bgPr>
     </p:bg>
     <p:spTree>
@@ -13900,6 +13975,7 @@
           <a:lstStyle/>
           <a:p>
             <a:pPr algn="ctr"/>
+            <a:endParaRPr/>
           </a:p>
         </p:txBody>
       </p:sp>
@@ -13920,7 +13996,7 @@
           <a:noFill/>
         </p:spPr>
         <p:txBody>
-          <a:bodyPr wrap="square" lIns="36576" rIns="36576" tIns="36576" bIns="36576" anchor="t">
+          <a:bodyPr wrap="square" lIns="36576" tIns="36576" rIns="36576" bIns="36576" anchor="t">
             <a:spAutoFit/>
           </a:bodyPr>
           <a:lstStyle/>
@@ -13987,6 +14063,7 @@
           <a:lstStyle/>
           <a:p>
             <a:pPr algn="ctr"/>
+            <a:endParaRPr/>
           </a:p>
         </p:txBody>
       </p:sp>
@@ -14007,7 +14084,7 @@
           <a:noFill/>
         </p:spPr>
         <p:txBody>
-          <a:bodyPr wrap="square" lIns="36576" rIns="36576" tIns="36576" bIns="36576" anchor="t">
+          <a:bodyPr wrap="square" lIns="36576" tIns="36576" rIns="36576" bIns="36576" anchor="t">
             <a:spAutoFit/>
           </a:bodyPr>
           <a:lstStyle/>
@@ -14049,7 +14126,7 @@
           <a:noFill/>
         </p:spPr>
         <p:txBody>
-          <a:bodyPr wrap="square" lIns="36576" rIns="36576" tIns="36576" bIns="36576" anchor="t">
+          <a:bodyPr wrap="square" lIns="36576" tIns="36576" rIns="36576" bIns="36576" anchor="t">
             <a:spAutoFit/>
           </a:bodyPr>
           <a:lstStyle/>
@@ -14118,6 +14195,7 @@
           <a:lstStyle/>
           <a:p>
             <a:pPr algn="ctr"/>
+            <a:endParaRPr/>
           </a:p>
         </p:txBody>
       </p:sp>
@@ -14163,6 +14241,7 @@
           <a:lstStyle/>
           <a:p>
             <a:pPr algn="ctr"/>
+            <a:endParaRPr/>
           </a:p>
         </p:txBody>
       </p:sp>
@@ -14183,7 +14262,7 @@
           <a:noFill/>
         </p:spPr>
         <p:txBody>
-          <a:bodyPr wrap="square" lIns="36576" rIns="36576" tIns="36576" bIns="36576" anchor="t">
+          <a:bodyPr wrap="square" lIns="36576" tIns="36576" rIns="36576" bIns="36576" anchor="t">
             <a:spAutoFit/>
           </a:bodyPr>
           <a:lstStyle/>
@@ -14225,7 +14304,7 @@
           <a:noFill/>
         </p:spPr>
         <p:txBody>
-          <a:bodyPr wrap="square" lIns="36576" rIns="36576" tIns="36576" bIns="36576" anchor="t">
+          <a:bodyPr wrap="square" lIns="36576" tIns="36576" rIns="36576" bIns="36576" anchor="t">
             <a:spAutoFit/>
           </a:bodyPr>
           <a:lstStyle/>
@@ -14294,6 +14373,7 @@
           <a:lstStyle/>
           <a:p>
             <a:pPr algn="ctr"/>
+            <a:endParaRPr/>
           </a:p>
         </p:txBody>
       </p:sp>
@@ -14339,6 +14419,7 @@
           <a:lstStyle/>
           <a:p>
             <a:pPr algn="ctr"/>
+            <a:endParaRPr/>
           </a:p>
         </p:txBody>
       </p:sp>
@@ -14359,7 +14440,7 @@
           <a:noFill/>
         </p:spPr>
         <p:txBody>
-          <a:bodyPr wrap="square" lIns="36576" rIns="36576" tIns="36576" bIns="36576" anchor="t">
+          <a:bodyPr wrap="square" lIns="36576" tIns="36576" rIns="36576" bIns="36576" anchor="t">
             <a:spAutoFit/>
           </a:bodyPr>
           <a:lstStyle/>
@@ -14401,7 +14482,7 @@
           <a:noFill/>
         </p:spPr>
         <p:txBody>
-          <a:bodyPr wrap="square" lIns="36576" rIns="36576" tIns="36576" bIns="36576" anchor="t">
+          <a:bodyPr wrap="square" lIns="36576" tIns="36576" rIns="36576" bIns="36576" anchor="t">
             <a:spAutoFit/>
           </a:bodyPr>
           <a:lstStyle/>
@@ -14470,6 +14551,7 @@
           <a:lstStyle/>
           <a:p>
             <a:pPr algn="ctr"/>
+            <a:endParaRPr/>
           </a:p>
         </p:txBody>
       </p:sp>
@@ -14515,6 +14597,7 @@
           <a:lstStyle/>
           <a:p>
             <a:pPr algn="ctr"/>
+            <a:endParaRPr/>
           </a:p>
         </p:txBody>
       </p:sp>
@@ -14535,7 +14618,7 @@
           <a:noFill/>
         </p:spPr>
         <p:txBody>
-          <a:bodyPr wrap="square" lIns="36576" rIns="36576" tIns="36576" bIns="36576" anchor="t">
+          <a:bodyPr wrap="square" lIns="36576" tIns="36576" rIns="36576" bIns="36576" anchor="t">
             <a:spAutoFit/>
           </a:bodyPr>
           <a:lstStyle/>
@@ -14577,7 +14660,7 @@
           <a:noFill/>
         </p:spPr>
         <p:txBody>
-          <a:bodyPr wrap="square" lIns="36576" rIns="36576" tIns="36576" bIns="36576" anchor="t">
+          <a:bodyPr wrap="square" lIns="36576" tIns="36576" rIns="36576" bIns="36576" anchor="t">
             <a:spAutoFit/>
           </a:bodyPr>
           <a:lstStyle/>
@@ -14646,6 +14729,7 @@
           <a:lstStyle/>
           <a:p>
             <a:pPr algn="ctr"/>
+            <a:endParaRPr/>
           </a:p>
         </p:txBody>
       </p:sp>
@@ -14691,6 +14775,7 @@
           <a:lstStyle/>
           <a:p>
             <a:pPr algn="ctr"/>
+            <a:endParaRPr/>
           </a:p>
         </p:txBody>
       </p:sp>
@@ -14711,7 +14796,7 @@
           <a:noFill/>
         </p:spPr>
         <p:txBody>
-          <a:bodyPr wrap="square" lIns="36576" rIns="36576" tIns="36576" bIns="36576" anchor="t">
+          <a:bodyPr wrap="square" lIns="36576" tIns="36576" rIns="36576" bIns="36576" anchor="t">
             <a:spAutoFit/>
           </a:bodyPr>
           <a:lstStyle/>
@@ -14753,7 +14838,7 @@
           <a:noFill/>
         </p:spPr>
         <p:txBody>
-          <a:bodyPr wrap="square" lIns="36576" rIns="36576" tIns="36576" bIns="36576" anchor="t">
+          <a:bodyPr wrap="square" lIns="36576" tIns="36576" rIns="36576" bIns="36576" anchor="t">
             <a:spAutoFit/>
           </a:bodyPr>
           <a:lstStyle/>
@@ -14822,6 +14907,7 @@
           <a:lstStyle/>
           <a:p>
             <a:pPr algn="ctr"/>
+            <a:endParaRPr/>
           </a:p>
         </p:txBody>
       </p:sp>
@@ -14842,7 +14928,7 @@
           <a:noFill/>
         </p:spPr>
         <p:txBody>
-          <a:bodyPr wrap="square" lIns="36576" rIns="36576" tIns="36576" bIns="36576" anchor="t">
+          <a:bodyPr wrap="square" lIns="36576" tIns="36576" rIns="36576" bIns="36576" anchor="t">
             <a:spAutoFit/>
           </a:bodyPr>
           <a:lstStyle/>
@@ -14883,6 +14969,7 @@
         <a:solidFill>
           <a:srgbClr val="FFFFFF"/>
         </a:solidFill>
+        <a:effectLst/>
       </p:bgPr>
     </p:bg>
     <p:spTree>
@@ -14941,6 +15028,7 @@
           <a:lstStyle/>
           <a:p>
             <a:pPr algn="ctr"/>
+            <a:endParaRPr/>
           </a:p>
         </p:txBody>
       </p:sp>
@@ -14961,7 +15049,7 @@
           <a:noFill/>
         </p:spPr>
         <p:txBody>
-          <a:bodyPr wrap="square" lIns="36576" rIns="36576" tIns="36576" bIns="36576" anchor="t">
+          <a:bodyPr wrap="square" lIns="36576" tIns="36576" rIns="36576" bIns="36576" anchor="t">
             <a:spAutoFit/>
           </a:bodyPr>
           <a:lstStyle/>
@@ -15028,6 +15116,7 @@
           <a:lstStyle/>
           <a:p>
             <a:pPr algn="ctr"/>
+            <a:endParaRPr/>
           </a:p>
         </p:txBody>
       </p:sp>
@@ -15048,7 +15137,7 @@
           <a:noFill/>
         </p:spPr>
         <p:txBody>
-          <a:bodyPr wrap="square" lIns="36576" rIns="36576" tIns="36576" bIns="36576" anchor="t">
+          <a:bodyPr wrap="square" lIns="36576" tIns="36576" rIns="36576" bIns="36576" anchor="t">
             <a:spAutoFit/>
           </a:bodyPr>
           <a:lstStyle/>
@@ -15090,7 +15179,7 @@
           <a:noFill/>
         </p:spPr>
         <p:txBody>
-          <a:bodyPr wrap="square" lIns="36576" rIns="36576" tIns="36576" bIns="36576" anchor="t">
+          <a:bodyPr wrap="square" lIns="36576" tIns="36576" rIns="36576" bIns="36576" anchor="t">
             <a:spAutoFit/>
           </a:bodyPr>
           <a:lstStyle/>
@@ -15159,6 +15248,7 @@
           <a:lstStyle/>
           <a:p>
             <a:pPr algn="ctr"/>
+            <a:endParaRPr/>
           </a:p>
         </p:txBody>
       </p:sp>
@@ -15204,6 +15294,7 @@
           <a:lstStyle/>
           <a:p>
             <a:pPr algn="ctr"/>
+            <a:endParaRPr/>
           </a:p>
         </p:txBody>
       </p:sp>
@@ -15224,7 +15315,7 @@
           <a:noFill/>
         </p:spPr>
         <p:txBody>
-          <a:bodyPr wrap="square" lIns="36576" rIns="36576" tIns="36576" bIns="36576" anchor="t">
+          <a:bodyPr wrap="square" lIns="36576" tIns="36576" rIns="36576" bIns="36576" anchor="t">
             <a:spAutoFit/>
           </a:bodyPr>
           <a:lstStyle/>
@@ -15266,7 +15357,7 @@
           <a:noFill/>
         </p:spPr>
         <p:txBody>
-          <a:bodyPr wrap="square" lIns="36576" rIns="36576" tIns="36576" bIns="36576" anchor="t">
+          <a:bodyPr wrap="square" lIns="36576" tIns="36576" rIns="36576" bIns="36576" anchor="t">
             <a:spAutoFit/>
           </a:bodyPr>
           <a:lstStyle/>
@@ -15335,6 +15426,7 @@
           <a:lstStyle/>
           <a:p>
             <a:pPr algn="ctr"/>
+            <a:endParaRPr/>
           </a:p>
         </p:txBody>
       </p:sp>
@@ -15355,7 +15447,7 @@
           <a:noFill/>
         </p:spPr>
         <p:txBody>
-          <a:bodyPr wrap="square" lIns="36576" rIns="36576" tIns="36576" bIns="36576" anchor="t">
+          <a:bodyPr wrap="square" lIns="36576" tIns="36576" rIns="36576" bIns="36576" anchor="t">
             <a:spAutoFit/>
           </a:bodyPr>
           <a:lstStyle/>
@@ -15397,7 +15489,7 @@
           <a:noFill/>
         </p:spPr>
         <p:txBody>
-          <a:bodyPr wrap="square" lIns="36576" rIns="36576" tIns="36576" bIns="36576" anchor="t">
+          <a:bodyPr wrap="square" lIns="36576" tIns="36576" rIns="36576" bIns="36576" anchor="t">
             <a:spAutoFit/>
           </a:bodyPr>
           <a:lstStyle/>
@@ -15466,6 +15558,7 @@
           <a:lstStyle/>
           <a:p>
             <a:pPr algn="ctr"/>
+            <a:endParaRPr/>
           </a:p>
         </p:txBody>
       </p:sp>
@@ -15511,6 +15604,7 @@
           <a:lstStyle/>
           <a:p>
             <a:pPr algn="ctr"/>
+            <a:endParaRPr/>
           </a:p>
         </p:txBody>
       </p:sp>
@@ -15531,7 +15625,7 @@
           <a:noFill/>
         </p:spPr>
         <p:txBody>
-          <a:bodyPr wrap="square" lIns="36576" rIns="36576" tIns="36576" bIns="36576" anchor="t">
+          <a:bodyPr wrap="square" lIns="36576" tIns="36576" rIns="36576" bIns="36576" anchor="t">
             <a:spAutoFit/>
           </a:bodyPr>
           <a:lstStyle/>
@@ -15573,7 +15667,7 @@
           <a:noFill/>
         </p:spPr>
         <p:txBody>
-          <a:bodyPr wrap="square" lIns="36576" rIns="36576" tIns="36576" bIns="36576" anchor="t">
+          <a:bodyPr wrap="square" lIns="36576" tIns="36576" rIns="36576" bIns="36576" anchor="t">
             <a:spAutoFit/>
           </a:bodyPr>
           <a:lstStyle/>
@@ -15642,6 +15736,7 @@
           <a:lstStyle/>
           <a:p>
             <a:pPr algn="ctr"/>
+            <a:endParaRPr/>
           </a:p>
         </p:txBody>
       </p:sp>
@@ -15662,7 +15757,7 @@
           <a:noFill/>
         </p:spPr>
         <p:txBody>
-          <a:bodyPr wrap="square" lIns="36576" rIns="36576" tIns="36576" bIns="36576" anchor="t">
+          <a:bodyPr wrap="square" lIns="36576" tIns="36576" rIns="36576" bIns="36576" anchor="t">
             <a:spAutoFit/>
           </a:bodyPr>
           <a:lstStyle/>
@@ -15704,7 +15799,7 @@
           <a:noFill/>
         </p:spPr>
         <p:txBody>
-          <a:bodyPr wrap="square" lIns="36576" rIns="36576" tIns="36576" bIns="36576" anchor="t">
+          <a:bodyPr wrap="square" lIns="36576" tIns="36576" rIns="36576" bIns="36576" anchor="t">
             <a:spAutoFit/>
           </a:bodyPr>
           <a:lstStyle/>
@@ -15773,6 +15868,7 @@
           <a:lstStyle/>
           <a:p>
             <a:pPr algn="ctr"/>
+            <a:endParaRPr/>
           </a:p>
         </p:txBody>
       </p:sp>
@@ -15818,6 +15914,7 @@
           <a:lstStyle/>
           <a:p>
             <a:pPr algn="ctr"/>
+            <a:endParaRPr/>
           </a:p>
         </p:txBody>
       </p:sp>
@@ -15838,7 +15935,7 @@
           <a:noFill/>
         </p:spPr>
         <p:txBody>
-          <a:bodyPr wrap="square" lIns="36576" rIns="36576" tIns="36576" bIns="36576" anchor="t">
+          <a:bodyPr wrap="square" lIns="36576" tIns="36576" rIns="36576" bIns="36576" anchor="t">
             <a:spAutoFit/>
           </a:bodyPr>
           <a:lstStyle/>
@@ -15880,7 +15977,7 @@
           <a:noFill/>
         </p:spPr>
         <p:txBody>
-          <a:bodyPr wrap="square" lIns="36576" rIns="36576" tIns="36576" bIns="36576" anchor="t">
+          <a:bodyPr wrap="square" lIns="36576" tIns="36576" rIns="36576" bIns="36576" anchor="t">
             <a:spAutoFit/>
           </a:bodyPr>
           <a:lstStyle/>
@@ -15949,6 +16046,7 @@
           <a:lstStyle/>
           <a:p>
             <a:pPr algn="ctr"/>
+            <a:endParaRPr/>
           </a:p>
         </p:txBody>
       </p:sp>
@@ -15969,7 +16067,7 @@
           <a:noFill/>
         </p:spPr>
         <p:txBody>
-          <a:bodyPr wrap="square" lIns="36576" rIns="36576" tIns="36576" bIns="36576" anchor="t">
+          <a:bodyPr wrap="square" lIns="36576" tIns="36576" rIns="36576" bIns="36576" anchor="t">
             <a:spAutoFit/>
           </a:bodyPr>
           <a:lstStyle/>
@@ -16011,7 +16109,7 @@
           <a:noFill/>
         </p:spPr>
         <p:txBody>
-          <a:bodyPr wrap="square" lIns="36576" rIns="36576" tIns="36576" bIns="36576" anchor="t">
+          <a:bodyPr wrap="square" lIns="36576" tIns="36576" rIns="36576" bIns="36576" anchor="t">
             <a:spAutoFit/>
           </a:bodyPr>
           <a:lstStyle/>
@@ -16080,6 +16178,7 @@
           <a:lstStyle/>
           <a:p>
             <a:pPr algn="ctr"/>
+            <a:endParaRPr/>
           </a:p>
         </p:txBody>
       </p:sp>
@@ -16125,6 +16224,7 @@
           <a:lstStyle/>
           <a:p>
             <a:pPr algn="ctr"/>
+            <a:endParaRPr/>
           </a:p>
         </p:txBody>
       </p:sp>
@@ -16145,7 +16245,7 @@
           <a:noFill/>
         </p:spPr>
         <p:txBody>
-          <a:bodyPr wrap="square" lIns="36576" rIns="36576" tIns="36576" bIns="36576" anchor="t">
+          <a:bodyPr wrap="square" lIns="36576" tIns="36576" rIns="36576" bIns="36576" anchor="t">
             <a:spAutoFit/>
           </a:bodyPr>
           <a:lstStyle/>
@@ -16187,7 +16287,7 @@
           <a:noFill/>
         </p:spPr>
         <p:txBody>
-          <a:bodyPr wrap="square" lIns="36576" rIns="36576" tIns="36576" bIns="36576" anchor="t">
+          <a:bodyPr wrap="square" lIns="36576" tIns="36576" rIns="36576" bIns="36576" anchor="t">
             <a:spAutoFit/>
           </a:bodyPr>
           <a:lstStyle/>
@@ -16256,6 +16356,7 @@
           <a:lstStyle/>
           <a:p>
             <a:pPr algn="ctr"/>
+            <a:endParaRPr/>
           </a:p>
         </p:txBody>
       </p:sp>
@@ -16276,7 +16377,7 @@
           <a:noFill/>
         </p:spPr>
         <p:txBody>
-          <a:bodyPr wrap="square" lIns="36576" rIns="36576" tIns="36576" bIns="36576" anchor="t">
+          <a:bodyPr wrap="square" lIns="36576" tIns="36576" rIns="36576" bIns="36576" anchor="t">
             <a:spAutoFit/>
           </a:bodyPr>
           <a:lstStyle/>
@@ -16345,6 +16446,7 @@
           <a:lstStyle/>
           <a:p>
             <a:pPr algn="ctr"/>
+            <a:endParaRPr/>
           </a:p>
         </p:txBody>
       </p:sp>
@@ -16390,6 +16492,7 @@
           <a:lstStyle/>
           <a:p>
             <a:pPr algn="ctr"/>
+            <a:endParaRPr/>
           </a:p>
         </p:txBody>
       </p:sp>
@@ -16410,7 +16513,7 @@
           <a:noFill/>
         </p:spPr>
         <p:txBody>
-          <a:bodyPr wrap="square" lIns="36576" rIns="36576" tIns="36576" bIns="36576" anchor="t">
+          <a:bodyPr wrap="square" lIns="36576" tIns="36576" rIns="36576" bIns="36576" anchor="t">
             <a:spAutoFit/>
           </a:bodyPr>
           <a:lstStyle/>
@@ -16452,7 +16555,7 @@
           <a:noFill/>
         </p:spPr>
         <p:txBody>
-          <a:bodyPr wrap="square" lIns="36576" rIns="36576" tIns="36576" bIns="36576" anchor="t">
+          <a:bodyPr wrap="square" lIns="36576" tIns="36576" rIns="36576" bIns="36576" anchor="t">
             <a:spAutoFit/>
           </a:bodyPr>
           <a:lstStyle/>
@@ -16486,7 +16589,7 @@
 </file>
 
 <file path=ppt/slides/slide8.xml><?xml version="1.0" encoding="utf-8"?>
-<p:sld xmlns:a="http://schemas.openxmlformats.org/drawingml/2006/main" xmlns:p="http://schemas.openxmlformats.org/presentationml/2006/main" xmlns:r="http://schemas.openxmlformats.org/officeDocument/2006/relationships">
+<p:sld xmlns:a="http://schemas.openxmlformats.org/drawingml/2006/main" xmlns:r="http://schemas.openxmlformats.org/officeDocument/2006/relationships" xmlns:p="http://schemas.openxmlformats.org/presentationml/2006/main">
   <p:cSld>
     <p:bg>
       <p:bgPr>
@@ -16502,7 +16605,14 @@
         <p:cNvGrpSpPr/>
         <p:nvPr/>
       </p:nvGrpSpPr>
-      <p:grpSpPr/>
+      <p:grpSpPr>
+        <a:xfrm>
+          <a:off x="0" y="0"/>
+          <a:ext cx="0" cy="0"/>
+          <a:chOff x="0" y="0"/>
+          <a:chExt cx="0" cy="0"/>
+        </a:xfrm>
+      </p:grpSpPr>
       <p:sp>
         <p:nvSpPr>
           <p:cNvPr id="2" name="Rectangle 1"/>
@@ -16545,6 +16655,7 @@
           <a:lstStyle/>
           <a:p>
             <a:pPr algn="ctr"/>
+            <a:endParaRPr/>
           </a:p>
         </p:txBody>
       </p:sp>
@@ -16565,7 +16676,7 @@
           <a:noFill/>
         </p:spPr>
         <p:txBody>
-          <a:bodyPr wrap="square" lIns="36576" rIns="36576" tIns="36576" bIns="36576" anchor="t">
+          <a:bodyPr wrap="square" lIns="36576" tIns="36576" rIns="36576" bIns="36576" anchor="t">
             <a:spAutoFit/>
           </a:bodyPr>
           <a:lstStyle/>
@@ -16632,6 +16743,7 @@
           <a:lstStyle/>
           <a:p>
             <a:pPr algn="ctr"/>
+            <a:endParaRPr/>
           </a:p>
         </p:txBody>
       </p:sp>
@@ -16652,7 +16764,7 @@
           <a:noFill/>
         </p:spPr>
         <p:txBody>
-          <a:bodyPr wrap="square" lIns="36576" rIns="36576" tIns="36576" bIns="36576" anchor="t">
+          <a:bodyPr wrap="square" lIns="36576" tIns="36576" rIns="36576" bIns="36576" anchor="t">
             <a:spAutoFit/>
           </a:bodyPr>
           <a:lstStyle/>
@@ -16694,7 +16806,7 @@
           <a:noFill/>
         </p:spPr>
         <p:txBody>
-          <a:bodyPr wrap="square" lIns="36576" rIns="36576" tIns="36576" bIns="36576" anchor="t">
+          <a:bodyPr wrap="square" lIns="36576" tIns="36576" rIns="36576" bIns="36576" anchor="t">
             <a:spAutoFit/>
           </a:bodyPr>
           <a:lstStyle/>
@@ -16738,10 +16850,34 @@
                 <a:tableStyleId>{5C22544A-7EE6-4342-B048-85BDC9FD1C3A}</a:tableStyleId>
               </a:tblPr>
               <a:tblGrid>
-                <a:gridCol w="2331720"/>
-                <a:gridCol w="1709928"/>
-                <a:gridCol w="1709928"/>
-                <a:gridCol w="2020824"/>
+                <a:gridCol w="2331720">
+                  <a:extLst>
+                    <a:ext uri="{9D8B030D-6E8A-4147-A177-3AD203B41FA5}">
+                      <a16:colId xmlns:a16="http://schemas.microsoft.com/office/drawing/2014/main" val="20000"/>
+                    </a:ext>
+                  </a:extLst>
+                </a:gridCol>
+                <a:gridCol w="1709928">
+                  <a:extLst>
+                    <a:ext uri="{9D8B030D-6E8A-4147-A177-3AD203B41FA5}">
+                      <a16:colId xmlns:a16="http://schemas.microsoft.com/office/drawing/2014/main" val="20001"/>
+                    </a:ext>
+                  </a:extLst>
+                </a:gridCol>
+                <a:gridCol w="1709928">
+                  <a:extLst>
+                    <a:ext uri="{9D8B030D-6E8A-4147-A177-3AD203B41FA5}">
+                      <a16:colId xmlns:a16="http://schemas.microsoft.com/office/drawing/2014/main" val="20002"/>
+                    </a:ext>
+                  </a:extLst>
+                </a:gridCol>
+                <a:gridCol w="2020824">
+                  <a:extLst>
+                    <a:ext uri="{9D8B030D-6E8A-4147-A177-3AD203B41FA5}">
+                      <a16:colId xmlns:a16="http://schemas.microsoft.com/office/drawing/2014/main" val="20003"/>
+                    </a:ext>
+                  </a:extLst>
+                </a:gridCol>
               </a:tblGrid>
               <a:tr h="411480">
                 <a:tc>
@@ -16836,6 +16972,11 @@
                     </a:solidFill>
                   </a:tcPr>
                 </a:tc>
+                <a:extLst>
+                  <a:ext uri="{0D108BD9-81ED-4DB2-BD59-A6C34878D82A}">
+                    <a16:rowId xmlns:a16="http://schemas.microsoft.com/office/drawing/2014/main" val="10000"/>
+                  </a:ext>
+                </a:extLst>
               </a:tr>
               <a:tr h="411480">
                 <a:tc>
@@ -16930,6 +17071,11 @@
                     </a:solidFill>
                   </a:tcPr>
                 </a:tc>
+                <a:extLst>
+                  <a:ext uri="{0D108BD9-81ED-4DB2-BD59-A6C34878D82A}">
+                    <a16:rowId xmlns:a16="http://schemas.microsoft.com/office/drawing/2014/main" val="10001"/>
+                  </a:ext>
+                </a:extLst>
               </a:tr>
               <a:tr h="411480">
                 <a:tc>
@@ -17024,6 +17170,11 @@
                     </a:solidFill>
                   </a:tcPr>
                 </a:tc>
+                <a:extLst>
+                  <a:ext uri="{0D108BD9-81ED-4DB2-BD59-A6C34878D82A}">
+                    <a16:rowId xmlns:a16="http://schemas.microsoft.com/office/drawing/2014/main" val="10002"/>
+                  </a:ext>
+                </a:extLst>
               </a:tr>
             </a:tbl>
           </a:graphicData>
@@ -17073,6 +17224,7 @@
           <a:lstStyle/>
           <a:p>
             <a:pPr algn="ctr"/>
+            <a:endParaRPr/>
           </a:p>
         </p:txBody>
       </p:sp>
@@ -17118,6 +17270,7 @@
           <a:lstStyle/>
           <a:p>
             <a:pPr algn="ctr"/>
+            <a:endParaRPr/>
           </a:p>
         </p:txBody>
       </p:sp>
@@ -17138,7 +17291,7 @@
           <a:noFill/>
         </p:spPr>
         <p:txBody>
-          <a:bodyPr wrap="square" lIns="36576" rIns="36576" tIns="36576" bIns="36576" anchor="t">
+          <a:bodyPr wrap="square" lIns="36576" tIns="36576" rIns="36576" bIns="36576" anchor="t">
             <a:spAutoFit/>
           </a:bodyPr>
           <a:lstStyle/>
@@ -17180,7 +17333,7 @@
           <a:noFill/>
         </p:spPr>
         <p:txBody>
-          <a:bodyPr wrap="square" lIns="36576" rIns="36576" tIns="36576" bIns="36576" anchor="t">
+          <a:bodyPr wrap="square" lIns="36576" tIns="36576" rIns="36576" bIns="36576" anchor="t">
             <a:spAutoFit/>
           </a:bodyPr>
           <a:lstStyle/>
@@ -17249,6 +17402,7 @@
           <a:lstStyle/>
           <a:p>
             <a:pPr algn="ctr"/>
+            <a:endParaRPr/>
           </a:p>
         </p:txBody>
       </p:sp>
@@ -17294,6 +17448,7 @@
           <a:lstStyle/>
           <a:p>
             <a:pPr algn="ctr"/>
+            <a:endParaRPr/>
           </a:p>
         </p:txBody>
       </p:sp>
@@ -17314,7 +17469,7 @@
           <a:noFill/>
         </p:spPr>
         <p:txBody>
-          <a:bodyPr wrap="square" lIns="36576" rIns="36576" tIns="36576" bIns="36576" anchor="t">
+          <a:bodyPr wrap="square" lIns="36576" tIns="36576" rIns="36576" bIns="36576" anchor="t">
             <a:spAutoFit/>
           </a:bodyPr>
           <a:lstStyle/>
@@ -17356,7 +17511,7 @@
           <a:noFill/>
         </p:spPr>
         <p:txBody>
-          <a:bodyPr wrap="square" lIns="36576" rIns="36576" tIns="36576" bIns="36576" anchor="t">
+          <a:bodyPr wrap="square" lIns="36576" tIns="36576" rIns="36576" bIns="36576" anchor="t">
             <a:spAutoFit/>
           </a:bodyPr>
           <a:lstStyle/>
@@ -17398,7 +17553,7 @@
           <a:noFill/>
         </p:spPr>
         <p:txBody>
-          <a:bodyPr wrap="square" lIns="36576" rIns="36576" tIns="36576" bIns="36576" anchor="t">
+          <a:bodyPr wrap="square" lIns="36576" tIns="36576" rIns="36576" bIns="36576" anchor="t">
             <a:spAutoFit/>
           </a:bodyPr>
           <a:lstStyle/>
@@ -17432,7 +17587,7 @@
 </file>
 
 <file path=ppt/slides/slide9.xml><?xml version="1.0" encoding="utf-8"?>
-<p:sld xmlns:a="http://schemas.openxmlformats.org/drawingml/2006/main" xmlns:p="http://schemas.openxmlformats.org/presentationml/2006/main" xmlns:r="http://schemas.openxmlformats.org/officeDocument/2006/relationships">
+<p:sld xmlns:a="http://schemas.openxmlformats.org/drawingml/2006/main" xmlns:r="http://schemas.openxmlformats.org/officeDocument/2006/relationships" xmlns:p="http://schemas.openxmlformats.org/presentationml/2006/main">
   <p:cSld>
     <p:bg>
       <p:bgPr>
@@ -17448,7 +17603,14 @@
         <p:cNvGrpSpPr/>
         <p:nvPr/>
       </p:nvGrpSpPr>
-      <p:grpSpPr/>
+      <p:grpSpPr>
+        <a:xfrm>
+          <a:off x="0" y="0"/>
+          <a:ext cx="0" cy="0"/>
+          <a:chOff x="0" y="0"/>
+          <a:chExt cx="0" cy="0"/>
+        </a:xfrm>
+      </p:grpSpPr>
       <p:sp>
         <p:nvSpPr>
           <p:cNvPr id="2" name="Rectangle 1"/>
@@ -17491,6 +17653,7 @@
           <a:lstStyle/>
           <a:p>
             <a:pPr algn="ctr"/>
+            <a:endParaRPr/>
           </a:p>
         </p:txBody>
       </p:sp>
@@ -17511,7 +17674,7 @@
           <a:noFill/>
         </p:spPr>
         <p:txBody>
-          <a:bodyPr wrap="square" lIns="36576" rIns="36576" tIns="36576" bIns="36576" anchor="t">
+          <a:bodyPr wrap="square" lIns="36576" tIns="36576" rIns="36576" bIns="36576" anchor="t">
             <a:spAutoFit/>
           </a:bodyPr>
           <a:lstStyle/>
@@ -17578,6 +17741,7 @@
           <a:lstStyle/>
           <a:p>
             <a:pPr algn="ctr"/>
+            <a:endParaRPr/>
           </a:p>
         </p:txBody>
       </p:sp>
@@ -17598,7 +17762,7 @@
           <a:noFill/>
         </p:spPr>
         <p:txBody>
-          <a:bodyPr wrap="square" lIns="36576" rIns="36576" tIns="36576" bIns="36576" anchor="t">
+          <a:bodyPr wrap="square" lIns="36576" tIns="36576" rIns="36576" bIns="36576" anchor="t">
             <a:spAutoFit/>
           </a:bodyPr>
           <a:lstStyle/>
@@ -17640,7 +17804,7 @@
           <a:noFill/>
         </p:spPr>
         <p:txBody>
-          <a:bodyPr wrap="square" lIns="36576" rIns="36576" tIns="36576" bIns="36576" anchor="t">
+          <a:bodyPr wrap="square" lIns="36576" tIns="36576" rIns="36576" bIns="36576" anchor="t">
             <a:spAutoFit/>
           </a:bodyPr>
           <a:lstStyle/>
@@ -17684,10 +17848,34 @@
                 <a:tableStyleId>{5C22544A-7EE6-4342-B048-85BDC9FD1C3A}</a:tableStyleId>
               </a:tblPr>
               <a:tblGrid>
-                <a:gridCol w="2360066"/>
-                <a:gridCol w="1953158"/>
-                <a:gridCol w="1953158"/>
-                <a:gridCol w="1871776"/>
+                <a:gridCol w="2360066">
+                  <a:extLst>
+                    <a:ext uri="{9D8B030D-6E8A-4147-A177-3AD203B41FA5}">
+                      <a16:colId xmlns:a16="http://schemas.microsoft.com/office/drawing/2014/main" val="20000"/>
+                    </a:ext>
+                  </a:extLst>
+                </a:gridCol>
+                <a:gridCol w="1953158">
+                  <a:extLst>
+                    <a:ext uri="{9D8B030D-6E8A-4147-A177-3AD203B41FA5}">
+                      <a16:colId xmlns:a16="http://schemas.microsoft.com/office/drawing/2014/main" val="20001"/>
+                    </a:ext>
+                  </a:extLst>
+                </a:gridCol>
+                <a:gridCol w="1953158">
+                  <a:extLst>
+                    <a:ext uri="{9D8B030D-6E8A-4147-A177-3AD203B41FA5}">
+                      <a16:colId xmlns:a16="http://schemas.microsoft.com/office/drawing/2014/main" val="20002"/>
+                    </a:ext>
+                  </a:extLst>
+                </a:gridCol>
+                <a:gridCol w="1871776">
+                  <a:extLst>
+                    <a:ext uri="{9D8B030D-6E8A-4147-A177-3AD203B41FA5}">
+                      <a16:colId xmlns:a16="http://schemas.microsoft.com/office/drawing/2014/main" val="20003"/>
+                    </a:ext>
+                  </a:extLst>
+                </a:gridCol>
               </a:tblGrid>
               <a:tr h="429768">
                 <a:tc>
@@ -17782,6 +17970,11 @@
                     </a:solidFill>
                   </a:tcPr>
                 </a:tc>
+                <a:extLst>
+                  <a:ext uri="{0D108BD9-81ED-4DB2-BD59-A6C34878D82A}">
+                    <a16:rowId xmlns:a16="http://schemas.microsoft.com/office/drawing/2014/main" val="10000"/>
+                  </a:ext>
+                </a:extLst>
               </a:tr>
               <a:tr h="429768">
                 <a:tc>
@@ -17876,6 +18069,11 @@
                     </a:solidFill>
                   </a:tcPr>
                 </a:tc>
+                <a:extLst>
+                  <a:ext uri="{0D108BD9-81ED-4DB2-BD59-A6C34878D82A}">
+                    <a16:rowId xmlns:a16="http://schemas.microsoft.com/office/drawing/2014/main" val="10001"/>
+                  </a:ext>
+                </a:extLst>
               </a:tr>
               <a:tr h="429768">
                 <a:tc>
@@ -17970,6 +18168,11 @@
                     </a:solidFill>
                   </a:tcPr>
                 </a:tc>
+                <a:extLst>
+                  <a:ext uri="{0D108BD9-81ED-4DB2-BD59-A6C34878D82A}">
+                    <a16:rowId xmlns:a16="http://schemas.microsoft.com/office/drawing/2014/main" val="10002"/>
+                  </a:ext>
+                </a:extLst>
               </a:tr>
               <a:tr h="429768">
                 <a:tc>
@@ -18064,6 +18267,11 @@
                     </a:solidFill>
                   </a:tcPr>
                 </a:tc>
+                <a:extLst>
+                  <a:ext uri="{0D108BD9-81ED-4DB2-BD59-A6C34878D82A}">
+                    <a16:rowId xmlns:a16="http://schemas.microsoft.com/office/drawing/2014/main" val="10003"/>
+                  </a:ext>
+                </a:extLst>
               </a:tr>
               <a:tr h="429768">
                 <a:tc>
@@ -18158,6 +18366,11 @@
                     </a:solidFill>
                   </a:tcPr>
                 </a:tc>
+                <a:extLst>
+                  <a:ext uri="{0D108BD9-81ED-4DB2-BD59-A6C34878D82A}">
+                    <a16:rowId xmlns:a16="http://schemas.microsoft.com/office/drawing/2014/main" val="10004"/>
+                  </a:ext>
+                </a:extLst>
               </a:tr>
             </a:tbl>
           </a:graphicData>
@@ -18207,6 +18420,7 @@
           <a:lstStyle/>
           <a:p>
             <a:pPr algn="ctr"/>
+            <a:endParaRPr/>
           </a:p>
         </p:txBody>
       </p:sp>
@@ -18252,6 +18466,7 @@
           <a:lstStyle/>
           <a:p>
             <a:pPr algn="ctr"/>
+            <a:endParaRPr/>
           </a:p>
         </p:txBody>
       </p:sp>
@@ -18272,7 +18487,7 @@
           <a:noFill/>
         </p:spPr>
         <p:txBody>
-          <a:bodyPr wrap="square" lIns="36576" rIns="36576" tIns="36576" bIns="36576" anchor="t">
+          <a:bodyPr wrap="square" lIns="36576" tIns="36576" rIns="36576" bIns="36576" anchor="t">
             <a:spAutoFit/>
           </a:bodyPr>
           <a:lstStyle/>
@@ -18314,7 +18529,7 @@
           <a:noFill/>
         </p:spPr>
         <p:txBody>
-          <a:bodyPr wrap="square" lIns="36576" rIns="36576" tIns="36576" bIns="36576" anchor="t">
+          <a:bodyPr wrap="square" lIns="36576" tIns="36576" rIns="36576" bIns="36576" anchor="t">
             <a:spAutoFit/>
           </a:bodyPr>
           <a:lstStyle/>
@@ -18383,6 +18598,7 @@
           <a:lstStyle/>
           <a:p>
             <a:pPr algn="ctr"/>
+            <a:endParaRPr/>
           </a:p>
         </p:txBody>
       </p:sp>
@@ -18428,6 +18644,7 @@
           <a:lstStyle/>
           <a:p>
             <a:pPr algn="ctr"/>
+            <a:endParaRPr/>
           </a:p>
         </p:txBody>
       </p:sp>
@@ -18448,7 +18665,7 @@
           <a:noFill/>
         </p:spPr>
         <p:txBody>
-          <a:bodyPr wrap="square" lIns="36576" rIns="36576" tIns="36576" bIns="36576" anchor="t">
+          <a:bodyPr wrap="square" lIns="36576" tIns="36576" rIns="36576" bIns="36576" anchor="t">
             <a:spAutoFit/>
           </a:bodyPr>
           <a:lstStyle/>
@@ -18490,7 +18707,7 @@
           <a:noFill/>
         </p:spPr>
         <p:txBody>
-          <a:bodyPr wrap="square" lIns="36576" rIns="36576" tIns="36576" bIns="36576" anchor="t">
+          <a:bodyPr wrap="square" lIns="36576" tIns="36576" rIns="36576" bIns="36576" anchor="t">
             <a:spAutoFit/>
           </a:bodyPr>
           <a:lstStyle/>
@@ -18816,4 +19033,299 @@
     </a:ext>
   </a:extLst>
 </a:theme>
+</file>
+
+<file path=ppt/theme/theme2.xml><?xml version="1.0" encoding="utf-8"?>
+<a:theme xmlns:a="http://schemas.openxmlformats.org/drawingml/2006/main" name="Office Theme">
+  <a:themeElements>
+    <a:clrScheme name="Office">
+      <a:dk1>
+        <a:sysClr val="windowText" lastClr="000000"/>
+      </a:dk1>
+      <a:lt1>
+        <a:sysClr val="window" lastClr="FFFFFF"/>
+      </a:lt1>
+      <a:dk2>
+        <a:srgbClr val="44546A"/>
+      </a:dk2>
+      <a:lt2>
+        <a:srgbClr val="E7E6E6"/>
+      </a:lt2>
+      <a:accent1>
+        <a:srgbClr val="4472C4"/>
+      </a:accent1>
+      <a:accent2>
+        <a:srgbClr val="ED7D31"/>
+      </a:accent2>
+      <a:accent3>
+        <a:srgbClr val="A5A5A5"/>
+      </a:accent3>
+      <a:accent4>
+        <a:srgbClr val="FFC000"/>
+      </a:accent4>
+      <a:accent5>
+        <a:srgbClr val="5B9BD5"/>
+      </a:accent5>
+      <a:accent6>
+        <a:srgbClr val="70AD47"/>
+      </a:accent6>
+      <a:hlink>
+        <a:srgbClr val="0563C1"/>
+      </a:hlink>
+      <a:folHlink>
+        <a:srgbClr val="954F72"/>
+      </a:folHlink>
+    </a:clrScheme>
+    <a:fontScheme name="Office">
+      <a:majorFont>
+        <a:latin typeface="Calibri Light" panose="020F0302020204030204"/>
+        <a:ea typeface=""/>
+        <a:cs typeface=""/>
+        <a:font script="Jpan" typeface="游ゴシック Light"/>
+        <a:font script="Hang" typeface="맑은 고딕"/>
+        <a:font script="Hans" typeface="等线 Light"/>
+        <a:font script="Hant" typeface="新細明體"/>
+        <a:font script="Arab" typeface="Times New Roman"/>
+        <a:font script="Hebr" typeface="Times New Roman"/>
+        <a:font script="Thai" typeface="Angsana New"/>
+        <a:font script="Ethi" typeface="Nyala"/>
+        <a:font script="Beng" typeface="Vrinda"/>
+        <a:font script="Gujr" typeface="Shruti"/>
+        <a:font script="Khmr" typeface="MoolBoran"/>
+        <a:font script="Knda" typeface="Tunga"/>
+        <a:font script="Guru" typeface="Raavi"/>
+        <a:font script="Cans" typeface="Euphemia"/>
+        <a:font script="Cher" typeface="Plantagenet Cherokee"/>
+        <a:font script="Yiii" typeface="Microsoft Yi Baiti"/>
+        <a:font script="Tibt" typeface="Microsoft Himalaya"/>
+        <a:font script="Thaa" typeface="MV Boli"/>
+        <a:font script="Deva" typeface="Mangal"/>
+        <a:font script="Telu" typeface="Gautami"/>
+        <a:font script="Taml" typeface="Latha"/>
+        <a:font script="Syrc" typeface="Estrangelo Edessa"/>
+        <a:font script="Orya" typeface="Kalinga"/>
+        <a:font script="Mlym" typeface="Kartika"/>
+        <a:font script="Laoo" typeface="DokChampa"/>
+        <a:font script="Sinh" typeface="Iskoola Pota"/>
+        <a:font script="Mong" typeface="Mongolian Baiti"/>
+        <a:font script="Viet" typeface="Times New Roman"/>
+        <a:font script="Uigh" typeface="Microsoft Uighur"/>
+        <a:font script="Geor" typeface="Sylfaen"/>
+        <a:font script="Armn" typeface="Arial"/>
+        <a:font script="Bugi" typeface="Leelawadee UI"/>
+        <a:font script="Bopo" typeface="Microsoft JhengHei"/>
+        <a:font script="Java" typeface="Javanese Text"/>
+        <a:font script="Lisu" typeface="Segoe UI"/>
+        <a:font script="Mymr" typeface="Myanmar Text"/>
+        <a:font script="Nkoo" typeface="Ebrima"/>
+        <a:font script="Olck" typeface="Nirmala UI"/>
+        <a:font script="Osma" typeface="Ebrima"/>
+        <a:font script="Phag" typeface="Phagspa"/>
+        <a:font script="Syrn" typeface="Estrangelo Edessa"/>
+        <a:font script="Syrj" typeface="Estrangelo Edessa"/>
+        <a:font script="Syre" typeface="Estrangelo Edessa"/>
+        <a:font script="Sora" typeface="Nirmala UI"/>
+        <a:font script="Tale" typeface="Microsoft Tai Le"/>
+        <a:font script="Talu" typeface="Microsoft New Tai Lue"/>
+        <a:font script="Tfng" typeface="Ebrima"/>
+      </a:majorFont>
+      <a:minorFont>
+        <a:latin typeface="Calibri" panose="020F0502020204030204"/>
+        <a:ea typeface=""/>
+        <a:cs typeface=""/>
+        <a:font script="Jpan" typeface="游ゴシック"/>
+        <a:font script="Hang" typeface="맑은 고딕"/>
+        <a:font script="Hans" typeface="等线"/>
+        <a:font script="Hant" typeface="新細明體"/>
+        <a:font script="Arab" typeface="Arial"/>
+        <a:font script="Hebr" typeface="Arial"/>
+        <a:font script="Thai" typeface="Cordia New"/>
+        <a:font script="Ethi" typeface="Nyala"/>
+        <a:font script="Beng" typeface="Vrinda"/>
+        <a:font script="Gujr" typeface="Shruti"/>
+        <a:font script="Khmr" typeface="DaunPenh"/>
+        <a:font script="Knda" typeface="Tunga"/>
+        <a:font script="Guru" typeface="Raavi"/>
+        <a:font script="Cans" typeface="Euphemia"/>
+        <a:font script="Cher" typeface="Plantagenet Cherokee"/>
+        <a:font script="Yiii" typeface="Microsoft Yi Baiti"/>
+        <a:font script="Tibt" typeface="Microsoft Himalaya"/>
+        <a:font script="Thaa" typeface="MV Boli"/>
+        <a:font script="Deva" typeface="Mangal"/>
+        <a:font script="Telu" typeface="Gautami"/>
+        <a:font script="Taml" typeface="Latha"/>
+        <a:font script="Syrc" typeface="Estrangelo Edessa"/>
+        <a:font script="Orya" typeface="Kalinga"/>
+        <a:font script="Mlym" typeface="Kartika"/>
+        <a:font script="Laoo" typeface="DokChampa"/>
+        <a:font script="Sinh" typeface="Iskoola Pota"/>
+        <a:font script="Mong" typeface="Mongolian Baiti"/>
+        <a:font script="Viet" typeface="Arial"/>
+        <a:font script="Uigh" typeface="Microsoft Uighur"/>
+        <a:font script="Geor" typeface="Sylfaen"/>
+        <a:font script="Armn" typeface="Arial"/>
+        <a:font script="Bugi" typeface="Leelawadee UI"/>
+        <a:font script="Bopo" typeface="Microsoft JhengHei"/>
+        <a:font script="Java" typeface="Javanese Text"/>
+        <a:font script="Lisu" typeface="Segoe UI"/>
+        <a:font script="Mymr" typeface="Myanmar Text"/>
+        <a:font script="Nkoo" typeface="Ebrima"/>
+        <a:font script="Olck" typeface="Nirmala UI"/>
+        <a:font script="Osma" typeface="Ebrima"/>
+        <a:font script="Phag" typeface="Phagspa"/>
+        <a:font script="Syrn" typeface="Estrangelo Edessa"/>
+        <a:font script="Syrj" typeface="Estrangelo Edessa"/>
+        <a:font script="Syre" typeface="Estrangelo Edessa"/>
+        <a:font script="Sora" typeface="Nirmala UI"/>
+        <a:font script="Tale" typeface="Microsoft Tai Le"/>
+        <a:font script="Talu" typeface="Microsoft New Tai Lue"/>
+        <a:font script="Tfng" typeface="Ebrima"/>
+      </a:minorFont>
+    </a:fontScheme>
+    <a:fmtScheme name="Office">
+      <a:fillStyleLst>
+        <a:solidFill>
+          <a:schemeClr val="phClr"/>
+        </a:solidFill>
+        <a:gradFill rotWithShape="1">
+          <a:gsLst>
+            <a:gs pos="0">
+              <a:schemeClr val="phClr">
+                <a:lumMod val="110000"/>
+                <a:satMod val="105000"/>
+                <a:tint val="67000"/>
+              </a:schemeClr>
+            </a:gs>
+            <a:gs pos="50000">
+              <a:schemeClr val="phClr">
+                <a:lumMod val="105000"/>
+                <a:satMod val="103000"/>
+                <a:tint val="73000"/>
+              </a:schemeClr>
+            </a:gs>
+            <a:gs pos="100000">
+              <a:schemeClr val="phClr">
+                <a:lumMod val="105000"/>
+                <a:satMod val="109000"/>
+                <a:tint val="81000"/>
+              </a:schemeClr>
+            </a:gs>
+          </a:gsLst>
+          <a:lin ang="5400000" scaled="0"/>
+        </a:gradFill>
+        <a:gradFill rotWithShape="1">
+          <a:gsLst>
+            <a:gs pos="0">
+              <a:schemeClr val="phClr">
+                <a:satMod val="103000"/>
+                <a:lumMod val="102000"/>
+                <a:tint val="94000"/>
+              </a:schemeClr>
+            </a:gs>
+            <a:gs pos="50000">
+              <a:schemeClr val="phClr">
+                <a:satMod val="110000"/>
+                <a:lumMod val="100000"/>
+                <a:shade val="100000"/>
+              </a:schemeClr>
+            </a:gs>
+            <a:gs pos="100000">
+              <a:schemeClr val="phClr">
+                <a:lumMod val="99000"/>
+                <a:satMod val="120000"/>
+                <a:shade val="78000"/>
+              </a:schemeClr>
+            </a:gs>
+          </a:gsLst>
+          <a:lin ang="5400000" scaled="0"/>
+        </a:gradFill>
+      </a:fillStyleLst>
+      <a:lnStyleLst>
+        <a:ln w="6350" cap="flat" cmpd="sng" algn="ctr">
+          <a:solidFill>
+            <a:schemeClr val="phClr"/>
+          </a:solidFill>
+          <a:prstDash val="solid"/>
+          <a:miter lim="800000"/>
+        </a:ln>
+        <a:ln w="12700" cap="flat" cmpd="sng" algn="ctr">
+          <a:solidFill>
+            <a:schemeClr val="phClr"/>
+          </a:solidFill>
+          <a:prstDash val="solid"/>
+          <a:miter lim="800000"/>
+        </a:ln>
+        <a:ln w="19050" cap="flat" cmpd="sng" algn="ctr">
+          <a:solidFill>
+            <a:schemeClr val="phClr"/>
+          </a:solidFill>
+          <a:prstDash val="solid"/>
+          <a:miter lim="800000"/>
+        </a:ln>
+      </a:lnStyleLst>
+      <a:effectStyleLst>
+        <a:effectStyle>
+          <a:effectLst/>
+        </a:effectStyle>
+        <a:effectStyle>
+          <a:effectLst/>
+        </a:effectStyle>
+        <a:effectStyle>
+          <a:effectLst>
+            <a:outerShdw blurRad="57150" dist="19050" dir="5400000" algn="ctr" rotWithShape="0">
+              <a:srgbClr val="000000">
+                <a:alpha val="63000"/>
+              </a:srgbClr>
+            </a:outerShdw>
+          </a:effectLst>
+        </a:effectStyle>
+      </a:effectStyleLst>
+      <a:bgFillStyleLst>
+        <a:solidFill>
+          <a:schemeClr val="phClr"/>
+        </a:solidFill>
+        <a:solidFill>
+          <a:schemeClr val="phClr">
+            <a:tint val="95000"/>
+            <a:satMod val="170000"/>
+          </a:schemeClr>
+        </a:solidFill>
+        <a:gradFill rotWithShape="1">
+          <a:gsLst>
+            <a:gs pos="0">
+              <a:schemeClr val="phClr">
+                <a:tint val="93000"/>
+                <a:satMod val="150000"/>
+                <a:shade val="98000"/>
+                <a:lumMod val="102000"/>
+              </a:schemeClr>
+            </a:gs>
+            <a:gs pos="50000">
+              <a:schemeClr val="phClr">
+                <a:tint val="98000"/>
+                <a:satMod val="130000"/>
+                <a:shade val="90000"/>
+                <a:lumMod val="103000"/>
+              </a:schemeClr>
+            </a:gs>
+            <a:gs pos="100000">
+              <a:schemeClr val="phClr">
+                <a:shade val="63000"/>
+                <a:satMod val="120000"/>
+              </a:schemeClr>
+            </a:gs>
+          </a:gsLst>
+          <a:lin ang="5400000" scaled="0"/>
+        </a:gradFill>
+      </a:bgFillStyleLst>
+    </a:fmtScheme>
+  </a:themeElements>
+  <a:objectDefaults/>
+  <a:extraClrSchemeLst/>
+  <a:extLst>
+    <a:ext uri="{05A4C25C-085E-4340-85A3-A5531E510DB2}">
+      <thm15:themeFamily xmlns:thm15="http://schemas.microsoft.com/office/thememl/2012/main" name="Office Theme" id="{62F939B6-93AF-4DB8-9C6B-D6C7DFDC589F}" vid="{4A3C46E8-61CC-4603-A589-7422A47A8E4A}"/>
+    </a:ext>
+  </a:extLst>
+</a:theme>
 </file>
</xml_diff>